<commit_message>
re-recorded disk structure for file systems
</commit_message>
<xml_diff>
--- a/slides/file_systems.pptx
+++ b/slides/file_systems.pptx
@@ -2494,10 +2494,7 @@
           <a:bodyPr/>
           <a:lstStyle/>
           <a:p>
-            <a:r>
-              <a:rPr lang="en-US" dirty="0"/>
-              <a:t>For disk layouts with one or more file systems, we will compare two boot and partitioning layouts: the Master Boot Record (MBR), an old legacy layout not much used today, and UEFI together with GPT, the GUID Partition Table, where GUID stands for Globally Unique Identifier.</a:t>
-            </a:r>
+            <a:endParaRPr lang="en-US" dirty="0"/>
           </a:p>
         </p:txBody>
       </p:sp>
@@ -2519,7 +2516,7 @@
             <a:fld id="{CAE0ABF5-7690-4623-B971-046A51D617CD}" type="slidenum">
               <a:rPr lang="en-US" altLang="en-US" smtClean="0"/>
               <a:pPr/>
-              <a:t>20</a:t>
+              <a:t>19</a:t>
             </a:fld>
             <a:endParaRPr lang="en-US" altLang="en-US"/>
           </a:p>
@@ -2528,7 +2525,7 @@
     </p:spTree>
     <p:extLst>
       <p:ext uri="{BB962C8B-B14F-4D97-AF65-F5344CB8AC3E}">
-        <p14:creationId xmlns:p14="http://schemas.microsoft.com/office/powerpoint/2010/main" val="3331246295"/>
+        <p14:creationId xmlns:p14="http://schemas.microsoft.com/office/powerpoint/2010/main" val="446753551"/>
       </p:ext>
     </p:extLst>
   </p:cSld>
@@ -2584,7 +2581,7 @@
           <a:p>
             <a:r>
               <a:rPr lang="en-US" dirty="0"/>
-              <a:t>With the MBR layout, a disk can have different partitions, each containing an independent file system. Each partition begins with a boot block, which contains executable code that, once loaded into memory, can start the operating system associated with that partition, if it contains one. The blocks after the boot block depend on the specific file system in that partition.</a:t>
+              <a:t>For disk layouts with one or more file systems, we will look at two boot and partitioning layouts: the Master Boot Record (MBR), an old legacy layout not much used today, and UEFI together with GPT, the GUID Partition Table, where GUID stands for Globally Unique Identifier.</a:t>
             </a:r>
           </a:p>
         </p:txBody>
@@ -2607,7 +2604,7 @@
             <a:fld id="{CAE0ABF5-7690-4623-B971-046A51D617CD}" type="slidenum">
               <a:rPr lang="en-US" altLang="en-US" smtClean="0"/>
               <a:pPr/>
-              <a:t>21</a:t>
+              <a:t>20</a:t>
             </a:fld>
             <a:endParaRPr lang="en-US" altLang="en-US"/>
           </a:p>
@@ -2616,7 +2613,7 @@
     </p:spTree>
     <p:extLst>
       <p:ext uri="{BB962C8B-B14F-4D97-AF65-F5344CB8AC3E}">
-        <p14:creationId xmlns:p14="http://schemas.microsoft.com/office/powerpoint/2010/main" val="3569829766"/>
+        <p14:creationId xmlns:p14="http://schemas.microsoft.com/office/powerpoint/2010/main" val="3331246295"/>
       </p:ext>
     </p:extLst>
   </p:cSld>
@@ -2672,7 +2669,7 @@
           <a:p>
             <a:r>
               <a:rPr lang="en-US" dirty="0"/>
-              <a:t>At the beginning of the disk, we have the Master Boot Record. The MBR is the first sector and contains both boot code and the partition table. When the machine starts, it loads the executable in the MBR, which reads the partition table and chooses which partition to use to load the operating system, possibly asking the user.</a:t>
+              <a:t>With the MBR layout, a disk can have different partitions, each containing an independent file system. Each partition begins with a boot block, which contains executable code that, once loaded into memory, can start the operating system associated with that partition, if the partition contains one OS. The blocks after the boot block depend on the specific file system in that partition.</a:t>
             </a:r>
           </a:p>
         </p:txBody>
@@ -2684,7 +2681,7 @@
             <a:spLocks noGrp="1"/>
           </p:cNvSpPr>
           <p:nvPr>
-            <p:ph type="sldNum" sz="quarter" idx="10"/>
+            <p:ph type="sldNum" sz="quarter" idx="5"/>
           </p:nvPr>
         </p:nvSpPr>
         <p:spPr/>
@@ -2695,7 +2692,7 @@
             <a:fld id="{CAE0ABF5-7690-4623-B971-046A51D617CD}" type="slidenum">
               <a:rPr lang="en-US" altLang="en-US" smtClean="0"/>
               <a:pPr/>
-              <a:t>22</a:t>
+              <a:t>21</a:t>
             </a:fld>
             <a:endParaRPr lang="en-US" altLang="en-US"/>
           </a:p>
@@ -2704,7 +2701,7 @@
     </p:spTree>
     <p:extLst>
       <p:ext uri="{BB962C8B-B14F-4D97-AF65-F5344CB8AC3E}">
-        <p14:creationId xmlns:p14="http://schemas.microsoft.com/office/powerpoint/2010/main" val="569530024"/>
+        <p14:creationId xmlns:p14="http://schemas.microsoft.com/office/powerpoint/2010/main" val="3569829766"/>
       </p:ext>
     </p:extLst>
   </p:cSld>
@@ -2760,7 +2757,7 @@
           <a:p>
             <a:r>
               <a:rPr lang="en-US" dirty="0"/>
-              <a:t>The partition table contains the addresses of the partitions. If one partition is marked as active, it is selected to load the operating system by reading that partition’s boot block.</a:t>
+              <a:t>At the beginning of the disk, we have the Master Boot Record. The MBR is the first sector and contains both boot code and the partition table. When the machine starts, it loads the executable in the MBR, which reads the partition table and chooses which partition to use to load the OS, possibly asking the user.</a:t>
             </a:r>
           </a:p>
         </p:txBody>
@@ -2772,7 +2769,7 @@
             <a:spLocks noGrp="1"/>
           </p:cNvSpPr>
           <p:nvPr>
-            <p:ph type="sldNum" sz="quarter" idx="5"/>
+            <p:ph type="sldNum" sz="quarter" idx="10"/>
           </p:nvPr>
         </p:nvSpPr>
         <p:spPr/>
@@ -2783,7 +2780,7 @@
             <a:fld id="{CAE0ABF5-7690-4623-B971-046A51D617CD}" type="slidenum">
               <a:rPr lang="en-US" altLang="en-US" smtClean="0"/>
               <a:pPr/>
-              <a:t>23</a:t>
+              <a:t>22</a:t>
             </a:fld>
             <a:endParaRPr lang="en-US" altLang="en-US"/>
           </a:p>
@@ -2792,7 +2789,7 @@
     </p:spTree>
     <p:extLst>
       <p:ext uri="{BB962C8B-B14F-4D97-AF65-F5344CB8AC3E}">
-        <p14:creationId xmlns:p14="http://schemas.microsoft.com/office/powerpoint/2010/main" val="139364435"/>
+        <p14:creationId xmlns:p14="http://schemas.microsoft.com/office/powerpoint/2010/main" val="569530024"/>
       </p:ext>
     </p:extLst>
   </p:cSld>
@@ -2848,7 +2845,7 @@
           <a:p>
             <a:r>
               <a:rPr lang="en-US" dirty="0"/>
-              <a:t>The MBR layout has been used for decades, especially when rotating disks were common in computers and laptops. It has several limitations. The MBR is limited to 512 bytes, including the partition table, so it often cannot contain all the code needed to boot and must load more code from another disk section. It also supports only up to four primary partitions. With legacy BIOS booting, execution starts in 16-bit real mode, using 16-bit registers and instructions, with no paging, which is no longer how modern hardware normally works. Finally, given the bits used for the partition start address and size, and the assumed sector size, MBR can only handle partitions up to about 2 TB.</a:t>
+              <a:t>The partition table contains the addresses of the partitions. If one partition is marked as active, it is selected to load the operating system by reading that partition’s boot block.</a:t>
             </a:r>
           </a:p>
         </p:txBody>
@@ -2871,7 +2868,7 @@
             <a:fld id="{CAE0ABF5-7690-4623-B971-046A51D617CD}" type="slidenum">
               <a:rPr lang="en-US" altLang="en-US" smtClean="0"/>
               <a:pPr/>
-              <a:t>24</a:t>
+              <a:t>23</a:t>
             </a:fld>
             <a:endParaRPr lang="en-US" altLang="en-US"/>
           </a:p>
@@ -2880,7 +2877,7 @@
     </p:spTree>
     <p:extLst>
       <p:ext uri="{BB962C8B-B14F-4D97-AF65-F5344CB8AC3E}">
-        <p14:creationId xmlns:p14="http://schemas.microsoft.com/office/powerpoint/2010/main" val="2807034590"/>
+        <p14:creationId xmlns:p14="http://schemas.microsoft.com/office/powerpoint/2010/main" val="139364435"/>
       </p:ext>
     </p:extLst>
   </p:cSld>
@@ -3021,7 +3018,7 @@
           <a:p>
             <a:r>
               <a:rPr lang="en-US" dirty="0"/>
-              <a:t>The common layout today is more complex. The first block is still reserved for an MBR in case legacy tools expect it. This is called the protective MBR. It tells legacy MBR tools that the disk is occupied, so they do not treat the GPT disk as empty.</a:t>
+              <a:t>The MBR layout has been used for decades, especially when rotating disks were common in computers and laptops. It has several limitations. The MBR is limited to 512 bytes, including the partition table, so it often cannot contain all the code needed to boot and must load more code from another disk section. It also supports only up to four primary partitions. With legacy BIOS booting, execution starts in 16-bit real mode, using 16-bit registers and instructions, without paging, which is no longer how modern hardware normally works. Finally, given the bits used for the partition start address and size, and the assumed sector size, MBR can only handle partitions up to about 2 TB.</a:t>
             </a:r>
           </a:p>
         </p:txBody>
@@ -3044,7 +3041,7 @@
             <a:fld id="{CAE0ABF5-7690-4623-B971-046A51D617CD}" type="slidenum">
               <a:rPr lang="en-US" altLang="en-US" smtClean="0"/>
               <a:pPr/>
-              <a:t>25</a:t>
+              <a:t>24</a:t>
             </a:fld>
             <a:endParaRPr lang="en-US" altLang="en-US"/>
           </a:p>
@@ -3053,7 +3050,7 @@
     </p:spTree>
     <p:extLst>
       <p:ext uri="{BB962C8B-B14F-4D97-AF65-F5344CB8AC3E}">
-        <p14:creationId xmlns:p14="http://schemas.microsoft.com/office/powerpoint/2010/main" val="645408309"/>
+        <p14:creationId xmlns:p14="http://schemas.microsoft.com/office/powerpoint/2010/main" val="2807034590"/>
       </p:ext>
     </p:extLst>
   </p:cSld>
@@ -3109,7 +3106,7 @@
           <a:p>
             <a:r>
               <a:rPr lang="en-US" dirty="0"/>
-              <a:t>After that, block 1 contains the GPT header, followed by the GPT partition-entry array. The actual partitions follow after that.</a:t>
+              <a:t>Let's move now to the Unified Extensible Firmware Interface (UEFI), which is the common layout today, and which is more complex but offers richer features. The first block is still reserved for an MBR in case legacy tools expect it. This is called the protective MBR. It tells legacy MBR tools that the disk is occupied, so they do not treat the GPT disk as empty.</a:t>
             </a:r>
           </a:p>
         </p:txBody>
@@ -3132,7 +3129,7 @@
             <a:fld id="{CAE0ABF5-7690-4623-B971-046A51D617CD}" type="slidenum">
               <a:rPr lang="en-US" altLang="en-US" smtClean="0"/>
               <a:pPr/>
-              <a:t>26</a:t>
+              <a:t>25</a:t>
             </a:fld>
             <a:endParaRPr lang="en-US" altLang="en-US"/>
           </a:p>
@@ -3141,7 +3138,7 @@
     </p:spTree>
     <p:extLst>
       <p:ext uri="{BB962C8B-B14F-4D97-AF65-F5344CB8AC3E}">
-        <p14:creationId xmlns:p14="http://schemas.microsoft.com/office/powerpoint/2010/main" val="2560155148"/>
+        <p14:creationId xmlns:p14="http://schemas.microsoft.com/office/powerpoint/2010/main" val="645408309"/>
       </p:ext>
     </p:extLst>
   </p:cSld>
@@ -3197,7 +3194,7 @@
           <a:p>
             <a:r>
               <a:rPr lang="en-US" dirty="0"/>
-              <a:t>At the end of the disk, there is a backup copy of the GPT. This backup contains a backup header and partition entries, so the partition table can be recovered if the primary GPT is damaged.</a:t>
+              <a:t>After that, block 1 contains the GPT header, followed by the GPT partition-entry array. The actual partitions follow after that.</a:t>
             </a:r>
           </a:p>
         </p:txBody>
@@ -3220,7 +3217,7 @@
             <a:fld id="{CAE0ABF5-7690-4623-B971-046A51D617CD}" type="slidenum">
               <a:rPr lang="en-US" altLang="en-US" smtClean="0"/>
               <a:pPr/>
-              <a:t>27</a:t>
+              <a:t>26</a:t>
             </a:fld>
             <a:endParaRPr lang="en-US" altLang="en-US"/>
           </a:p>
@@ -3229,7 +3226,7 @@
     </p:spTree>
     <p:extLst>
       <p:ext uri="{BB962C8B-B14F-4D97-AF65-F5344CB8AC3E}">
-        <p14:creationId xmlns:p14="http://schemas.microsoft.com/office/powerpoint/2010/main" val="2187331419"/>
+        <p14:creationId xmlns:p14="http://schemas.microsoft.com/office/powerpoint/2010/main" val="2560155148"/>
       </p:ext>
     </p:extLst>
   </p:cSld>
@@ -3285,33 +3282,7 @@
           <a:p>
             <a:r>
               <a:rPr lang="en-US" dirty="0"/>
-              <a:t>One difference here is that we are not only loading a small program that decides which operating system to load. Instead, there is a specific partition called the EFI System Partition, which contains a proper file system and executables. More concretely, UEFI loads </a:t>
-            </a:r>
-            <a:r>
-              <a:rPr lang="en-US" sz="1200" kern="1200" dirty="0">
-                <a:solidFill>
-                  <a:schemeClr val="tx1"/>
-                </a:solidFill>
-                <a:latin typeface="Times New Roman" pitchFamily="18" charset="0"/>
-                <a:ea typeface="MS PGothic" pitchFamily="34" charset="-128"/>
-                <a:cs typeface="ＭＳ Ｐゴシック" charset="0"/>
-              </a:rPr>
-              <a:t>.</a:t>
-            </a:r>
-            <a:r>
-              <a:rPr lang="en-US" sz="1200" kern="1200" dirty="0" err="1">
-                <a:solidFill>
-                  <a:schemeClr val="tx1"/>
-                </a:solidFill>
-                <a:latin typeface="Times New Roman" pitchFamily="18" charset="0"/>
-                <a:ea typeface="MS PGothic" pitchFamily="34" charset="-128"/>
-                <a:cs typeface="ＭＳ Ｐゴシック" charset="0"/>
-              </a:rPr>
-              <a:t>efi</a:t>
-            </a:r>
-            <a:r>
-              <a:rPr lang="en-US" dirty="0"/>
-              <a:t> boot programs from the EFI System Partition.</a:t>
+              <a:t>At the end of the disk, there is a backup copy of the GPT. This backup contains a backup header and partition entries, so the partition table can be recovered if the primary GPT is damaged.</a:t>
             </a:r>
           </a:p>
         </p:txBody>
@@ -3334,7 +3305,7 @@
             <a:fld id="{CAE0ABF5-7690-4623-B971-046A51D617CD}" type="slidenum">
               <a:rPr lang="en-US" altLang="en-US" smtClean="0"/>
               <a:pPr/>
-              <a:t>28</a:t>
+              <a:t>27</a:t>
             </a:fld>
             <a:endParaRPr lang="en-US" altLang="en-US"/>
           </a:p>
@@ -3343,7 +3314,7 @@
     </p:spTree>
     <p:extLst>
       <p:ext uri="{BB962C8B-B14F-4D97-AF65-F5344CB8AC3E}">
-        <p14:creationId xmlns:p14="http://schemas.microsoft.com/office/powerpoint/2010/main" val="1129618516"/>
+        <p14:creationId xmlns:p14="http://schemas.microsoft.com/office/powerpoint/2010/main" val="2187331419"/>
       </p:ext>
     </p:extLst>
   </p:cSld>
@@ -3372,212 +3343,84 @@
       </p:grpSpPr>
       <p:sp>
         <p:nvSpPr>
-          <p:cNvPr id="70658" name="Rectangle 7"/>
-          <p:cNvSpPr>
-            <a:spLocks noGrp="1" noChangeArrowheads="1"/>
+          <p:cNvPr id="2" name="Slide Image Placeholder 1"/>
+          <p:cNvSpPr>
+            <a:spLocks noGrp="1" noRot="1" noChangeAspect="1"/>
+          </p:cNvSpPr>
+          <p:nvPr>
+            <p:ph type="sldImg"/>
+          </p:nvPr>
+        </p:nvSpPr>
+        <p:spPr/>
+      </p:sp>
+      <p:sp>
+        <p:nvSpPr>
+          <p:cNvPr id="3" name="Notes Placeholder 2"/>
+          <p:cNvSpPr>
+            <a:spLocks noGrp="1"/>
+          </p:cNvSpPr>
+          <p:nvPr>
+            <p:ph type="body" idx="1"/>
+          </p:nvPr>
+        </p:nvSpPr>
+        <p:spPr/>
+        <p:txBody>
+          <a:bodyPr/>
+          <a:lstStyle/>
+          <a:p>
+            <a:r>
+              <a:rPr lang="en-US" dirty="0"/>
+              <a:t>One difference with MBR is that we are not only loading a small program that decides which operating system to load. Instead, there is a specific partition called the EFI System Partition, which contains a proper file system and executables. More concretely, UEFI loads </a:t>
+            </a:r>
+            <a:r>
+              <a:rPr lang="en-US" sz="1200" kern="1200" dirty="0">
+                <a:solidFill>
+                  <a:schemeClr val="tx1"/>
+                </a:solidFill>
+                <a:latin typeface="Times New Roman" pitchFamily="18" charset="0"/>
+                <a:ea typeface="MS PGothic" pitchFamily="34" charset="-128"/>
+                <a:cs typeface="ＭＳ Ｐゴシック" charset="0"/>
+              </a:rPr>
+              <a:t>.</a:t>
+            </a:r>
+            <a:r>
+              <a:rPr lang="en-US" sz="1200" kern="1200" dirty="0" err="1">
+                <a:solidFill>
+                  <a:schemeClr val="tx1"/>
+                </a:solidFill>
+                <a:latin typeface="Times New Roman" pitchFamily="18" charset="0"/>
+                <a:ea typeface="MS PGothic" pitchFamily="34" charset="-128"/>
+                <a:cs typeface="ＭＳ Ｐゴシック" charset="0"/>
+              </a:rPr>
+              <a:t>efi</a:t>
+            </a:r>
+            <a:r>
+              <a:rPr lang="en-US" dirty="0"/>
+              <a:t> boot programs from the EFI System Partition.</a:t>
+            </a:r>
+          </a:p>
+        </p:txBody>
+      </p:sp>
+      <p:sp>
+        <p:nvSpPr>
+          <p:cNvPr id="4" name="Slide Number Placeholder 3"/>
+          <p:cNvSpPr>
+            <a:spLocks noGrp="1"/>
           </p:cNvSpPr>
           <p:nvPr>
             <p:ph type="sldNum" sz="quarter" idx="5"/>
           </p:nvPr>
         </p:nvSpPr>
-        <p:spPr>
-          <a:noFill/>
-          <a:ln/>
-          <a:extLst>
-            <a:ext uri="{909E8E84-426E-40DD-AFC4-6F175D3DCCD1}">
-              <a14:hiddenFill xmlns:a14="http://schemas.microsoft.com/office/drawing/2010/main">
-                <a:solidFill>
-                  <a:srgbClr val="FFFFFF"/>
-                </a:solidFill>
-              </a14:hiddenFill>
-            </a:ext>
-            <a:ext uri="{91240B29-F687-4F45-9708-019B960494DF}">
-              <a14:hiddenLine xmlns:a14="http://schemas.microsoft.com/office/drawing/2010/main" w="9525">
-                <a:solidFill>
-                  <a:srgbClr val="000000"/>
-                </a:solidFill>
-                <a:miter lim="800000"/>
-                <a:headEnd/>
-                <a:tailEnd/>
-              </a14:hiddenLine>
-            </a:ext>
-          </a:extLst>
-        </p:spPr>
+        <p:spPr/>
         <p:txBody>
           <a:bodyPr/>
-          <a:lstStyle>
-            <a:lvl1pPr defTabSz="923925">
-              <a:defRPr>
-                <a:solidFill>
-                  <a:schemeClr val="tx1"/>
-                </a:solidFill>
-                <a:latin typeface="Verdana" panose="020B0604030504040204" pitchFamily="34" charset="0"/>
-                <a:ea typeface="MS PGothic" panose="020B0600070205080204" pitchFamily="34" charset="-128"/>
-              </a:defRPr>
-            </a:lvl1pPr>
-            <a:lvl2pPr marL="742950" indent="-285750" defTabSz="923925">
-              <a:defRPr>
-                <a:solidFill>
-                  <a:schemeClr val="tx1"/>
-                </a:solidFill>
-                <a:latin typeface="Verdana" panose="020B0604030504040204" pitchFamily="34" charset="0"/>
-                <a:ea typeface="MS PGothic" panose="020B0600070205080204" pitchFamily="34" charset="-128"/>
-              </a:defRPr>
-            </a:lvl2pPr>
-            <a:lvl3pPr marL="1143000" indent="-228600" defTabSz="923925">
-              <a:defRPr>
-                <a:solidFill>
-                  <a:schemeClr val="tx1"/>
-                </a:solidFill>
-                <a:latin typeface="Verdana" panose="020B0604030504040204" pitchFamily="34" charset="0"/>
-                <a:ea typeface="MS PGothic" panose="020B0600070205080204" pitchFamily="34" charset="-128"/>
-              </a:defRPr>
-            </a:lvl3pPr>
-            <a:lvl4pPr marL="1600200" indent="-228600" defTabSz="923925">
-              <a:defRPr>
-                <a:solidFill>
-                  <a:schemeClr val="tx1"/>
-                </a:solidFill>
-                <a:latin typeface="Verdana" panose="020B0604030504040204" pitchFamily="34" charset="0"/>
-                <a:ea typeface="MS PGothic" panose="020B0600070205080204" pitchFamily="34" charset="-128"/>
-              </a:defRPr>
-            </a:lvl4pPr>
-            <a:lvl5pPr marL="2057400" indent="-228600" defTabSz="923925">
-              <a:defRPr>
-                <a:solidFill>
-                  <a:schemeClr val="tx1"/>
-                </a:solidFill>
-                <a:latin typeface="Verdana" panose="020B0604030504040204" pitchFamily="34" charset="0"/>
-                <a:ea typeface="MS PGothic" panose="020B0600070205080204" pitchFamily="34" charset="-128"/>
-              </a:defRPr>
-            </a:lvl5pPr>
-            <a:lvl6pPr marL="2514600" indent="-228600" defTabSz="923925" eaLnBrk="0" fontAlgn="base" hangingPunct="0">
-              <a:spcBef>
-                <a:spcPct val="0"/>
-              </a:spcBef>
-              <a:spcAft>
-                <a:spcPct val="0"/>
-              </a:spcAft>
-              <a:defRPr>
-                <a:solidFill>
-                  <a:schemeClr val="tx1"/>
-                </a:solidFill>
-                <a:latin typeface="Verdana" panose="020B0604030504040204" pitchFamily="34" charset="0"/>
-                <a:ea typeface="MS PGothic" panose="020B0600070205080204" pitchFamily="34" charset="-128"/>
-              </a:defRPr>
-            </a:lvl6pPr>
-            <a:lvl7pPr marL="2971800" indent="-228600" defTabSz="923925" eaLnBrk="0" fontAlgn="base" hangingPunct="0">
-              <a:spcBef>
-                <a:spcPct val="0"/>
-              </a:spcBef>
-              <a:spcAft>
-                <a:spcPct val="0"/>
-              </a:spcAft>
-              <a:defRPr>
-                <a:solidFill>
-                  <a:schemeClr val="tx1"/>
-                </a:solidFill>
-                <a:latin typeface="Verdana" panose="020B0604030504040204" pitchFamily="34" charset="0"/>
-                <a:ea typeface="MS PGothic" panose="020B0600070205080204" pitchFamily="34" charset="-128"/>
-              </a:defRPr>
-            </a:lvl7pPr>
-            <a:lvl8pPr marL="3429000" indent="-228600" defTabSz="923925" eaLnBrk="0" fontAlgn="base" hangingPunct="0">
-              <a:spcBef>
-                <a:spcPct val="0"/>
-              </a:spcBef>
-              <a:spcAft>
-                <a:spcPct val="0"/>
-              </a:spcAft>
-              <a:defRPr>
-                <a:solidFill>
-                  <a:schemeClr val="tx1"/>
-                </a:solidFill>
-                <a:latin typeface="Verdana" panose="020B0604030504040204" pitchFamily="34" charset="0"/>
-                <a:ea typeface="MS PGothic" panose="020B0600070205080204" pitchFamily="34" charset="-128"/>
-              </a:defRPr>
-            </a:lvl8pPr>
-            <a:lvl9pPr marL="3886200" indent="-228600" defTabSz="923925" eaLnBrk="0" fontAlgn="base" hangingPunct="0">
-              <a:spcBef>
-                <a:spcPct val="0"/>
-              </a:spcBef>
-              <a:spcAft>
-                <a:spcPct val="0"/>
-              </a:spcAft>
-              <a:defRPr>
-                <a:solidFill>
-                  <a:schemeClr val="tx1"/>
-                </a:solidFill>
-                <a:latin typeface="Verdana" panose="020B0604030504040204" pitchFamily="34" charset="0"/>
-                <a:ea typeface="MS PGothic" panose="020B0600070205080204" pitchFamily="34" charset="-128"/>
-              </a:defRPr>
-            </a:lvl9pPr>
-          </a:lstStyle>
-          <a:p>
-            <a:fld id="{2C753A3D-1B93-4C61-AD40-6D3DDE54932A}" type="slidenum">
-              <a:rPr lang="en-US" altLang="en-US">
-                <a:latin typeface="Times New Roman" panose="02020603050405020304" pitchFamily="18" charset="0"/>
-              </a:rPr>
+          <a:lstStyle/>
+          <a:p>
+            <a:fld id="{CAE0ABF5-7690-4623-B971-046A51D617CD}" type="slidenum">
+              <a:rPr lang="en-US" altLang="en-US" smtClean="0"/>
               <a:pPr/>
-              <a:t>30</a:t>
+              <a:t>28</a:t>
             </a:fld>
-            <a:endParaRPr lang="en-US" altLang="en-US">
-              <a:latin typeface="Times New Roman" panose="02020603050405020304" pitchFamily="18" charset="0"/>
-            </a:endParaRPr>
-          </a:p>
-        </p:txBody>
-      </p:sp>
-      <p:sp>
-        <p:nvSpPr>
-          <p:cNvPr id="70659" name="Rectangle 2"/>
-          <p:cNvSpPr>
-            <a:spLocks noGrp="1" noRot="1" noChangeAspect="1" noChangeArrowheads="1" noTextEdit="1"/>
-          </p:cNvSpPr>
-          <p:nvPr>
-            <p:ph type="sldImg"/>
-          </p:nvPr>
-        </p:nvSpPr>
-        <p:spPr>
-          <a:ln/>
-        </p:spPr>
-      </p:sp>
-      <p:sp>
-        <p:nvSpPr>
-          <p:cNvPr id="70660" name="Rectangle 3"/>
-          <p:cNvSpPr>
-            <a:spLocks noGrp="1" noChangeArrowheads="1"/>
-          </p:cNvSpPr>
-          <p:nvPr>
-            <p:ph type="body" idx="1"/>
-          </p:nvPr>
-        </p:nvSpPr>
-        <p:spPr>
-          <a:noFill/>
-          <a:ln/>
-          <a:extLst>
-            <a:ext uri="{909E8E84-426E-40DD-AFC4-6F175D3DCCD1}">
-              <a14:hiddenFill xmlns:a14="http://schemas.microsoft.com/office/drawing/2010/main">
-                <a:solidFill>
-                  <a:srgbClr val="FFFFFF"/>
-                </a:solidFill>
-              </a14:hiddenFill>
-            </a:ext>
-            <a:ext uri="{91240B29-F687-4F45-9708-019B960494DF}">
-              <a14:hiddenLine xmlns:a14="http://schemas.microsoft.com/office/drawing/2010/main" w="9525">
-                <a:solidFill>
-                  <a:srgbClr val="000000"/>
-                </a:solidFill>
-                <a:miter lim="800000"/>
-                <a:headEnd/>
-                <a:tailEnd/>
-              </a14:hiddenLine>
-            </a:ext>
-          </a:extLst>
-        </p:spPr>
-        <p:txBody>
-          <a:bodyPr/>
-          <a:lstStyle/>
-          <a:p>
-            <a:pPr eaLnBrk="1" hangingPunct="1"/>
             <a:endParaRPr lang="en-US" altLang="en-US"/>
           </a:p>
         </p:txBody>
@@ -3585,7 +3428,7 @@
     </p:spTree>
     <p:extLst>
       <p:ext uri="{BB962C8B-B14F-4D97-AF65-F5344CB8AC3E}">
-        <p14:creationId xmlns:p14="http://schemas.microsoft.com/office/powerpoint/2010/main" val="417564640"/>
+        <p14:creationId xmlns:p14="http://schemas.microsoft.com/office/powerpoint/2010/main" val="1129618516"/>
       </p:ext>
     </p:extLst>
   </p:cSld>
@@ -3614,7 +3457,7 @@
       </p:grpSpPr>
       <p:sp>
         <p:nvSpPr>
-          <p:cNvPr id="72706" name="Rectangle 7"/>
+          <p:cNvPr id="70658" name="Rectangle 7"/>
           <p:cNvSpPr>
             <a:spLocks noGrp="1" noChangeArrowheads="1"/>
           </p:cNvSpPr>
@@ -3755,12 +3598,12 @@
             </a:lvl9pPr>
           </a:lstStyle>
           <a:p>
-            <a:fld id="{41ECA4A7-BC25-4844-A19F-534D35A6113C}" type="slidenum">
+            <a:fld id="{2C753A3D-1B93-4C61-AD40-6D3DDE54932A}" type="slidenum">
               <a:rPr lang="en-US" altLang="en-US">
                 <a:latin typeface="Times New Roman" panose="02020603050405020304" pitchFamily="18" charset="0"/>
               </a:rPr>
               <a:pPr/>
-              <a:t>31</a:t>
+              <a:t>30</a:t>
             </a:fld>
             <a:endParaRPr lang="en-US" altLang="en-US">
               <a:latin typeface="Times New Roman" panose="02020603050405020304" pitchFamily="18" charset="0"/>
@@ -3770,7 +3613,7 @@
       </p:sp>
       <p:sp>
         <p:nvSpPr>
-          <p:cNvPr id="72707" name="Rectangle 2"/>
+          <p:cNvPr id="70659" name="Rectangle 2"/>
           <p:cNvSpPr>
             <a:spLocks noGrp="1" noRot="1" noChangeAspect="1" noChangeArrowheads="1" noTextEdit="1"/>
           </p:cNvSpPr>
@@ -3784,7 +3627,7 @@
       </p:sp>
       <p:sp>
         <p:nvSpPr>
-          <p:cNvPr id="72708" name="Rectangle 3"/>
+          <p:cNvPr id="70660" name="Rectangle 3"/>
           <p:cNvSpPr>
             <a:spLocks noGrp="1" noChangeArrowheads="1"/>
           </p:cNvSpPr>
@@ -3827,7 +3670,7 @@
     </p:spTree>
     <p:extLst>
       <p:ext uri="{BB962C8B-B14F-4D97-AF65-F5344CB8AC3E}">
-        <p14:creationId xmlns:p14="http://schemas.microsoft.com/office/powerpoint/2010/main" val="3993913530"/>
+        <p14:creationId xmlns:p14="http://schemas.microsoft.com/office/powerpoint/2010/main" val="417564640"/>
       </p:ext>
     </p:extLst>
   </p:cSld>
@@ -3856,7 +3699,7 @@
       </p:grpSpPr>
       <p:sp>
         <p:nvSpPr>
-          <p:cNvPr id="73730" name="Rectangle 7"/>
+          <p:cNvPr id="72706" name="Rectangle 7"/>
           <p:cNvSpPr>
             <a:spLocks noGrp="1" noChangeArrowheads="1"/>
           </p:cNvSpPr>
@@ -3997,12 +3840,12 @@
             </a:lvl9pPr>
           </a:lstStyle>
           <a:p>
-            <a:fld id="{B7A13DDA-9CA8-4AE6-948C-F2D6D91DD053}" type="slidenum">
+            <a:fld id="{41ECA4A7-BC25-4844-A19F-534D35A6113C}" type="slidenum">
               <a:rPr lang="en-US" altLang="en-US">
                 <a:latin typeface="Times New Roman" panose="02020603050405020304" pitchFamily="18" charset="0"/>
               </a:rPr>
               <a:pPr/>
-              <a:t>32</a:t>
+              <a:t>31</a:t>
             </a:fld>
             <a:endParaRPr lang="en-US" altLang="en-US">
               <a:latin typeface="Times New Roman" panose="02020603050405020304" pitchFamily="18" charset="0"/>
@@ -4012,7 +3855,7 @@
       </p:sp>
       <p:sp>
         <p:nvSpPr>
-          <p:cNvPr id="73731" name="Rectangle 2"/>
+          <p:cNvPr id="72707" name="Rectangle 2"/>
           <p:cNvSpPr>
             <a:spLocks noGrp="1" noRot="1" noChangeAspect="1" noChangeArrowheads="1" noTextEdit="1"/>
           </p:cNvSpPr>
@@ -4026,7 +3869,7 @@
       </p:sp>
       <p:sp>
         <p:nvSpPr>
-          <p:cNvPr id="73732" name="Rectangle 3"/>
+          <p:cNvPr id="72708" name="Rectangle 3"/>
           <p:cNvSpPr>
             <a:spLocks noGrp="1" noChangeArrowheads="1"/>
           </p:cNvSpPr>
@@ -4069,7 +3912,7 @@
     </p:spTree>
     <p:extLst>
       <p:ext uri="{BB962C8B-B14F-4D97-AF65-F5344CB8AC3E}">
-        <p14:creationId xmlns:p14="http://schemas.microsoft.com/office/powerpoint/2010/main" val="3813879666"/>
+        <p14:creationId xmlns:p14="http://schemas.microsoft.com/office/powerpoint/2010/main" val="3993913530"/>
       </p:ext>
     </p:extLst>
   </p:cSld>
@@ -4098,7 +3941,7 @@
       </p:grpSpPr>
       <p:sp>
         <p:nvSpPr>
-          <p:cNvPr id="74754" name="Rectangle 7"/>
+          <p:cNvPr id="73730" name="Rectangle 7"/>
           <p:cNvSpPr>
             <a:spLocks noGrp="1" noChangeArrowheads="1"/>
           </p:cNvSpPr>
@@ -4239,12 +4082,12 @@
             </a:lvl9pPr>
           </a:lstStyle>
           <a:p>
-            <a:fld id="{C48E2A61-7116-4526-90DA-8DA2FD642289}" type="slidenum">
+            <a:fld id="{B7A13DDA-9CA8-4AE6-948C-F2D6D91DD053}" type="slidenum">
               <a:rPr lang="en-US" altLang="en-US">
                 <a:latin typeface="Times New Roman" panose="02020603050405020304" pitchFamily="18" charset="0"/>
               </a:rPr>
               <a:pPr/>
-              <a:t>33</a:t>
+              <a:t>32</a:t>
             </a:fld>
             <a:endParaRPr lang="en-US" altLang="en-US">
               <a:latin typeface="Times New Roman" panose="02020603050405020304" pitchFamily="18" charset="0"/>
@@ -4254,7 +4097,7 @@
       </p:sp>
       <p:sp>
         <p:nvSpPr>
-          <p:cNvPr id="74755" name="Rectangle 2"/>
+          <p:cNvPr id="73731" name="Rectangle 2"/>
           <p:cNvSpPr>
             <a:spLocks noGrp="1" noRot="1" noChangeAspect="1" noChangeArrowheads="1" noTextEdit="1"/>
           </p:cNvSpPr>
@@ -4268,7 +4111,7 @@
       </p:sp>
       <p:sp>
         <p:nvSpPr>
-          <p:cNvPr id="74756" name="Rectangle 3"/>
+          <p:cNvPr id="73732" name="Rectangle 3"/>
           <p:cNvSpPr>
             <a:spLocks noGrp="1" noChangeArrowheads="1"/>
           </p:cNvSpPr>
@@ -4311,7 +4154,7 @@
     </p:spTree>
     <p:extLst>
       <p:ext uri="{BB962C8B-B14F-4D97-AF65-F5344CB8AC3E}">
-        <p14:creationId xmlns:p14="http://schemas.microsoft.com/office/powerpoint/2010/main" val="1400426395"/>
+        <p14:creationId xmlns:p14="http://schemas.microsoft.com/office/powerpoint/2010/main" val="3813879666"/>
       </p:ext>
     </p:extLst>
   </p:cSld>
@@ -4340,7 +4183,7 @@
       </p:grpSpPr>
       <p:sp>
         <p:nvSpPr>
-          <p:cNvPr id="77826" name="Rectangle 7"/>
+          <p:cNvPr id="74754" name="Rectangle 7"/>
           <p:cNvSpPr>
             <a:spLocks noGrp="1" noChangeArrowheads="1"/>
           </p:cNvSpPr>
@@ -4481,12 +4324,12 @@
             </a:lvl9pPr>
           </a:lstStyle>
           <a:p>
-            <a:fld id="{EBFE31E4-C513-4D0A-AA76-C1514DD89C25}" type="slidenum">
+            <a:fld id="{C48E2A61-7116-4526-90DA-8DA2FD642289}" type="slidenum">
               <a:rPr lang="en-US" altLang="en-US">
                 <a:latin typeface="Times New Roman" panose="02020603050405020304" pitchFamily="18" charset="0"/>
               </a:rPr>
               <a:pPr/>
-              <a:t>35</a:t>
+              <a:t>33</a:t>
             </a:fld>
             <a:endParaRPr lang="en-US" altLang="en-US">
               <a:latin typeface="Times New Roman" panose="02020603050405020304" pitchFamily="18" charset="0"/>
@@ -4496,7 +4339,7 @@
       </p:sp>
       <p:sp>
         <p:nvSpPr>
-          <p:cNvPr id="77827" name="Rectangle 2"/>
+          <p:cNvPr id="74755" name="Rectangle 2"/>
           <p:cNvSpPr>
             <a:spLocks noGrp="1" noRot="1" noChangeAspect="1" noChangeArrowheads="1" noTextEdit="1"/>
           </p:cNvSpPr>
@@ -4510,7 +4353,7 @@
       </p:sp>
       <p:sp>
         <p:nvSpPr>
-          <p:cNvPr id="77828" name="Rectangle 3"/>
+          <p:cNvPr id="74756" name="Rectangle 3"/>
           <p:cNvSpPr>
             <a:spLocks noGrp="1" noChangeArrowheads="1"/>
           </p:cNvSpPr>
@@ -4553,7 +4396,7 @@
     </p:spTree>
     <p:extLst>
       <p:ext uri="{BB962C8B-B14F-4D97-AF65-F5344CB8AC3E}">
-        <p14:creationId xmlns:p14="http://schemas.microsoft.com/office/powerpoint/2010/main" val="924837221"/>
+        <p14:creationId xmlns:p14="http://schemas.microsoft.com/office/powerpoint/2010/main" val="1400426395"/>
       </p:ext>
     </p:extLst>
   </p:cSld>
@@ -4728,7 +4571,7 @@
                 <a:latin typeface="Times New Roman" panose="02020603050405020304" pitchFamily="18" charset="0"/>
               </a:rPr>
               <a:pPr/>
-              <a:t>36</a:t>
+              <a:t>35</a:t>
             </a:fld>
             <a:endParaRPr lang="en-US" altLang="en-US">
               <a:latin typeface="Times New Roman" panose="02020603050405020304" pitchFamily="18" charset="0"/>
@@ -4787,66 +4630,15 @@
           <a:bodyPr/>
           <a:lstStyle/>
           <a:p>
-            <a:pPr marL="228600" indent="-228600" eaLnBrk="1" hangingPunct="1">
-              <a:buAutoNum type="arabicParenR"/>
-            </a:pPr>
-            <a:r>
-              <a:rPr lang="en-US" altLang="en-US" baseline="0" dirty="0"/>
-              <a:t>1 – yes… well depends, maybe w/list was created before or by another user</a:t>
-            </a:r>
-          </a:p>
-          <a:p>
-            <a:pPr marL="228600" indent="-228600" eaLnBrk="1" hangingPunct="1">
-              <a:buAutoNum type="arabicParenR"/>
-            </a:pPr>
-            <a:r>
-              <a:rPr lang="en-US" altLang="en-US" baseline="0" dirty="0"/>
-              <a:t>1 – no… well depends, maybe it was created by this user</a:t>
-            </a:r>
-          </a:p>
-          <a:p>
-            <a:pPr marL="228600" indent="-228600" eaLnBrk="1" hangingPunct="1">
-              <a:buAutoNum type="arabicParenR"/>
-            </a:pPr>
-            <a:r>
-              <a:rPr lang="en-US" altLang="en-US" baseline="0" dirty="0"/>
-              <a:t>2 – yes… but then the other folder might not notice at all</a:t>
-            </a:r>
-          </a:p>
-          <a:p>
-            <a:pPr marL="228600" indent="-228600" eaLnBrk="1" hangingPunct="1">
-              <a:buAutoNum type="arabicParenR"/>
-            </a:pPr>
-            <a:r>
-              <a:rPr lang="en-US" altLang="en-US" baseline="0" dirty="0"/>
-              <a:t>2 – no… other folders will notice, we will save time, but users will get an error</a:t>
-            </a:r>
-          </a:p>
-          <a:p>
-            <a:pPr marL="228600" indent="-228600" eaLnBrk="1" hangingPunct="1">
-              <a:buAutoNum type="arabicParenR"/>
-            </a:pPr>
-            <a:r>
-              <a:rPr lang="en-US" altLang="en-US" baseline="0" dirty="0"/>
-              <a:t>3 – we can keep track of them… extra info to maintain</a:t>
-            </a:r>
-          </a:p>
-          <a:p>
-            <a:pPr marL="228600" indent="-228600" eaLnBrk="1" hangingPunct="1">
-              <a:buAutoNum type="arabicParenR"/>
-            </a:pPr>
-            <a:r>
-              <a:rPr lang="en-US" altLang="en-US" baseline="0" dirty="0"/>
-              <a:t>3 – we can look for them… might take forever…</a:t>
-            </a:r>
-            <a:endParaRPr lang="en-US" altLang="en-US" dirty="0"/>
+            <a:pPr eaLnBrk="1" hangingPunct="1"/>
+            <a:endParaRPr lang="en-US" altLang="en-US"/>
           </a:p>
         </p:txBody>
       </p:sp>
     </p:spTree>
     <p:extLst>
       <p:ext uri="{BB962C8B-B14F-4D97-AF65-F5344CB8AC3E}">
-        <p14:creationId xmlns:p14="http://schemas.microsoft.com/office/powerpoint/2010/main" val="171875551"/>
+        <p14:creationId xmlns:p14="http://schemas.microsoft.com/office/powerpoint/2010/main" val="924837221"/>
       </p:ext>
     </p:extLst>
   </p:cSld>
@@ -5117,7 +4909,7 @@
       </p:grpSpPr>
       <p:sp>
         <p:nvSpPr>
-          <p:cNvPr id="70658" name="Rectangle 7"/>
+          <p:cNvPr id="77826" name="Rectangle 7"/>
           <p:cNvSpPr>
             <a:spLocks noGrp="1" noChangeArrowheads="1"/>
           </p:cNvSpPr>
@@ -5151,7 +4943,7 @@
         <p:txBody>
           <a:bodyPr/>
           <a:lstStyle>
-            <a:lvl1pPr defTabSz="930275">
+            <a:lvl1pPr defTabSz="923925">
               <a:defRPr>
                 <a:solidFill>
                   <a:schemeClr val="tx1"/>
@@ -5160,7 +4952,7 @@
                 <a:ea typeface="MS PGothic" panose="020B0600070205080204" pitchFamily="34" charset="-128"/>
               </a:defRPr>
             </a:lvl1pPr>
-            <a:lvl2pPr marL="742950" indent="-285750" defTabSz="930275">
+            <a:lvl2pPr marL="742950" indent="-285750" defTabSz="923925">
               <a:defRPr>
                 <a:solidFill>
                   <a:schemeClr val="tx1"/>
@@ -5169,7 +4961,7 @@
                 <a:ea typeface="MS PGothic" panose="020B0600070205080204" pitchFamily="34" charset="-128"/>
               </a:defRPr>
             </a:lvl2pPr>
-            <a:lvl3pPr marL="1143000" indent="-228600" defTabSz="930275">
+            <a:lvl3pPr marL="1143000" indent="-228600" defTabSz="923925">
               <a:defRPr>
                 <a:solidFill>
                   <a:schemeClr val="tx1"/>
@@ -5178,7 +4970,7 @@
                 <a:ea typeface="MS PGothic" panose="020B0600070205080204" pitchFamily="34" charset="-128"/>
               </a:defRPr>
             </a:lvl3pPr>
-            <a:lvl4pPr marL="1600200" indent="-228600" defTabSz="930275">
+            <a:lvl4pPr marL="1600200" indent="-228600" defTabSz="923925">
               <a:defRPr>
                 <a:solidFill>
                   <a:schemeClr val="tx1"/>
@@ -5187,7 +4979,7 @@
                 <a:ea typeface="MS PGothic" panose="020B0600070205080204" pitchFamily="34" charset="-128"/>
               </a:defRPr>
             </a:lvl4pPr>
-            <a:lvl5pPr marL="2057400" indent="-228600" defTabSz="930275">
+            <a:lvl5pPr marL="2057400" indent="-228600" defTabSz="923925">
               <a:defRPr>
                 <a:solidFill>
                   <a:schemeClr val="tx1"/>
@@ -5196,7 +4988,7 @@
                 <a:ea typeface="MS PGothic" panose="020B0600070205080204" pitchFamily="34" charset="-128"/>
               </a:defRPr>
             </a:lvl5pPr>
-            <a:lvl6pPr marL="2514600" indent="-228600" defTabSz="930275" eaLnBrk="0" fontAlgn="base" hangingPunct="0">
+            <a:lvl6pPr marL="2514600" indent="-228600" defTabSz="923925" eaLnBrk="0" fontAlgn="base" hangingPunct="0">
               <a:spcBef>
                 <a:spcPct val="0"/>
               </a:spcBef>
@@ -5211,7 +5003,7 @@
                 <a:ea typeface="MS PGothic" panose="020B0600070205080204" pitchFamily="34" charset="-128"/>
               </a:defRPr>
             </a:lvl6pPr>
-            <a:lvl7pPr marL="2971800" indent="-228600" defTabSz="930275" eaLnBrk="0" fontAlgn="base" hangingPunct="0">
+            <a:lvl7pPr marL="2971800" indent="-228600" defTabSz="923925" eaLnBrk="0" fontAlgn="base" hangingPunct="0">
               <a:spcBef>
                 <a:spcPct val="0"/>
               </a:spcBef>
@@ -5226,7 +5018,7 @@
                 <a:ea typeface="MS PGothic" panose="020B0600070205080204" pitchFamily="34" charset="-128"/>
               </a:defRPr>
             </a:lvl7pPr>
-            <a:lvl8pPr marL="3429000" indent="-228600" defTabSz="930275" eaLnBrk="0" fontAlgn="base" hangingPunct="0">
+            <a:lvl8pPr marL="3429000" indent="-228600" defTabSz="923925" eaLnBrk="0" fontAlgn="base" hangingPunct="0">
               <a:spcBef>
                 <a:spcPct val="0"/>
               </a:spcBef>
@@ -5241,7 +5033,7 @@
                 <a:ea typeface="MS PGothic" panose="020B0600070205080204" pitchFamily="34" charset="-128"/>
               </a:defRPr>
             </a:lvl8pPr>
-            <a:lvl9pPr marL="3886200" indent="-228600" defTabSz="930275" eaLnBrk="0" fontAlgn="base" hangingPunct="0">
+            <a:lvl9pPr marL="3886200" indent="-228600" defTabSz="923925" eaLnBrk="0" fontAlgn="base" hangingPunct="0">
               <a:spcBef>
                 <a:spcPct val="0"/>
               </a:spcBef>
@@ -5258,12 +5050,12 @@
             </a:lvl9pPr>
           </a:lstStyle>
           <a:p>
-            <a:fld id="{962E0F78-D4D3-433B-8D40-C98934B24EFF}" type="slidenum">
+            <a:fld id="{EBFE31E4-C513-4D0A-AA76-C1514DD89C25}" type="slidenum">
               <a:rPr lang="en-US" altLang="en-US">
                 <a:latin typeface="Times New Roman" panose="02020603050405020304" pitchFamily="18" charset="0"/>
               </a:rPr>
               <a:pPr/>
-              <a:t>38</a:t>
+              <a:t>36</a:t>
             </a:fld>
             <a:endParaRPr lang="en-US" altLang="en-US">
               <a:latin typeface="Times New Roman" panose="02020603050405020304" pitchFamily="18" charset="0"/>
@@ -5273,7 +5065,7 @@
       </p:sp>
       <p:sp>
         <p:nvSpPr>
-          <p:cNvPr id="70659" name="Rectangle 2"/>
+          <p:cNvPr id="77827" name="Rectangle 2"/>
           <p:cNvSpPr>
             <a:spLocks noGrp="1" noRot="1" noChangeAspect="1" noChangeArrowheads="1" noTextEdit="1"/>
           </p:cNvSpPr>
@@ -5287,7 +5079,7 @@
       </p:sp>
       <p:sp>
         <p:nvSpPr>
-          <p:cNvPr id="70660" name="Rectangle 3"/>
+          <p:cNvPr id="77828" name="Rectangle 3"/>
           <p:cNvSpPr>
             <a:spLocks noGrp="1" noChangeArrowheads="1"/>
           </p:cNvSpPr>
@@ -5322,17 +5114,66 @@
           <a:bodyPr/>
           <a:lstStyle/>
           <a:p>
-            <a:pPr eaLnBrk="1" hangingPunct="1"/>
-            <a:endParaRPr lang="en-US" altLang="en-US" dirty="0">
-              <a:latin typeface="Times New Roman" panose="02020603050405020304" pitchFamily="18" charset="0"/>
-            </a:endParaRPr>
+            <a:pPr marL="228600" indent="-228600" eaLnBrk="1" hangingPunct="1">
+              <a:buAutoNum type="arabicParenR"/>
+            </a:pPr>
+            <a:r>
+              <a:rPr lang="en-US" altLang="en-US" baseline="0" dirty="0"/>
+              <a:t>1 – yes… well depends, maybe w/list was created before or by another user</a:t>
+            </a:r>
+          </a:p>
+          <a:p>
+            <a:pPr marL="228600" indent="-228600" eaLnBrk="1" hangingPunct="1">
+              <a:buAutoNum type="arabicParenR"/>
+            </a:pPr>
+            <a:r>
+              <a:rPr lang="en-US" altLang="en-US" baseline="0" dirty="0"/>
+              <a:t>1 – no… well depends, maybe it was created by this user</a:t>
+            </a:r>
+          </a:p>
+          <a:p>
+            <a:pPr marL="228600" indent="-228600" eaLnBrk="1" hangingPunct="1">
+              <a:buAutoNum type="arabicParenR"/>
+            </a:pPr>
+            <a:r>
+              <a:rPr lang="en-US" altLang="en-US" baseline="0" dirty="0"/>
+              <a:t>2 – yes… but then the other folder might not notice at all</a:t>
+            </a:r>
+          </a:p>
+          <a:p>
+            <a:pPr marL="228600" indent="-228600" eaLnBrk="1" hangingPunct="1">
+              <a:buAutoNum type="arabicParenR"/>
+            </a:pPr>
+            <a:r>
+              <a:rPr lang="en-US" altLang="en-US" baseline="0" dirty="0"/>
+              <a:t>2 – no… other folders will notice, we will save time, but users will get an error</a:t>
+            </a:r>
+          </a:p>
+          <a:p>
+            <a:pPr marL="228600" indent="-228600" eaLnBrk="1" hangingPunct="1">
+              <a:buAutoNum type="arabicParenR"/>
+            </a:pPr>
+            <a:r>
+              <a:rPr lang="en-US" altLang="en-US" baseline="0" dirty="0"/>
+              <a:t>3 – we can keep track of them… extra info to maintain</a:t>
+            </a:r>
+          </a:p>
+          <a:p>
+            <a:pPr marL="228600" indent="-228600" eaLnBrk="1" hangingPunct="1">
+              <a:buAutoNum type="arabicParenR"/>
+            </a:pPr>
+            <a:r>
+              <a:rPr lang="en-US" altLang="en-US" baseline="0" dirty="0"/>
+              <a:t>3 – we can look for them… might take forever…</a:t>
+            </a:r>
+            <a:endParaRPr lang="en-US" altLang="en-US" dirty="0"/>
           </a:p>
         </p:txBody>
       </p:sp>
     </p:spTree>
     <p:extLst>
       <p:ext uri="{BB962C8B-B14F-4D97-AF65-F5344CB8AC3E}">
-        <p14:creationId xmlns:p14="http://schemas.microsoft.com/office/powerpoint/2010/main" val="3200878199"/>
+        <p14:creationId xmlns:p14="http://schemas.microsoft.com/office/powerpoint/2010/main" val="171875551"/>
       </p:ext>
     </p:extLst>
   </p:cSld>
@@ -5361,63 +5202,222 @@
       </p:grpSpPr>
       <p:sp>
         <p:nvSpPr>
-          <p:cNvPr id="2" name="Slide Image Placeholder 1"/>
-          <p:cNvSpPr>
-            <a:spLocks noGrp="1" noRot="1" noChangeAspect="1"/>
+          <p:cNvPr id="70658" name="Rectangle 7"/>
+          <p:cNvSpPr>
+            <a:spLocks noGrp="1" noChangeArrowheads="1"/>
+          </p:cNvSpPr>
+          <p:nvPr>
+            <p:ph type="sldNum" sz="quarter" idx="5"/>
+          </p:nvPr>
+        </p:nvSpPr>
+        <p:spPr>
+          <a:noFill/>
+          <a:ln/>
+          <a:extLst>
+            <a:ext uri="{909E8E84-426E-40DD-AFC4-6F175D3DCCD1}">
+              <a14:hiddenFill xmlns:a14="http://schemas.microsoft.com/office/drawing/2010/main">
+                <a:solidFill>
+                  <a:srgbClr val="FFFFFF"/>
+                </a:solidFill>
+              </a14:hiddenFill>
+            </a:ext>
+            <a:ext uri="{91240B29-F687-4F45-9708-019B960494DF}">
+              <a14:hiddenLine xmlns:a14="http://schemas.microsoft.com/office/drawing/2010/main" w="9525">
+                <a:solidFill>
+                  <a:srgbClr val="000000"/>
+                </a:solidFill>
+                <a:miter lim="800000"/>
+                <a:headEnd/>
+                <a:tailEnd/>
+              </a14:hiddenLine>
+            </a:ext>
+          </a:extLst>
+        </p:spPr>
+        <p:txBody>
+          <a:bodyPr/>
+          <a:lstStyle>
+            <a:lvl1pPr defTabSz="930275">
+              <a:defRPr>
+                <a:solidFill>
+                  <a:schemeClr val="tx1"/>
+                </a:solidFill>
+                <a:latin typeface="Verdana" panose="020B0604030504040204" pitchFamily="34" charset="0"/>
+                <a:ea typeface="MS PGothic" panose="020B0600070205080204" pitchFamily="34" charset="-128"/>
+              </a:defRPr>
+            </a:lvl1pPr>
+            <a:lvl2pPr marL="742950" indent="-285750" defTabSz="930275">
+              <a:defRPr>
+                <a:solidFill>
+                  <a:schemeClr val="tx1"/>
+                </a:solidFill>
+                <a:latin typeface="Verdana" panose="020B0604030504040204" pitchFamily="34" charset="0"/>
+                <a:ea typeface="MS PGothic" panose="020B0600070205080204" pitchFamily="34" charset="-128"/>
+              </a:defRPr>
+            </a:lvl2pPr>
+            <a:lvl3pPr marL="1143000" indent="-228600" defTabSz="930275">
+              <a:defRPr>
+                <a:solidFill>
+                  <a:schemeClr val="tx1"/>
+                </a:solidFill>
+                <a:latin typeface="Verdana" panose="020B0604030504040204" pitchFamily="34" charset="0"/>
+                <a:ea typeface="MS PGothic" panose="020B0600070205080204" pitchFamily="34" charset="-128"/>
+              </a:defRPr>
+            </a:lvl3pPr>
+            <a:lvl4pPr marL="1600200" indent="-228600" defTabSz="930275">
+              <a:defRPr>
+                <a:solidFill>
+                  <a:schemeClr val="tx1"/>
+                </a:solidFill>
+                <a:latin typeface="Verdana" panose="020B0604030504040204" pitchFamily="34" charset="0"/>
+                <a:ea typeface="MS PGothic" panose="020B0600070205080204" pitchFamily="34" charset="-128"/>
+              </a:defRPr>
+            </a:lvl4pPr>
+            <a:lvl5pPr marL="2057400" indent="-228600" defTabSz="930275">
+              <a:defRPr>
+                <a:solidFill>
+                  <a:schemeClr val="tx1"/>
+                </a:solidFill>
+                <a:latin typeface="Verdana" panose="020B0604030504040204" pitchFamily="34" charset="0"/>
+                <a:ea typeface="MS PGothic" panose="020B0600070205080204" pitchFamily="34" charset="-128"/>
+              </a:defRPr>
+            </a:lvl5pPr>
+            <a:lvl6pPr marL="2514600" indent="-228600" defTabSz="930275" eaLnBrk="0" fontAlgn="base" hangingPunct="0">
+              <a:spcBef>
+                <a:spcPct val="0"/>
+              </a:spcBef>
+              <a:spcAft>
+                <a:spcPct val="0"/>
+              </a:spcAft>
+              <a:defRPr>
+                <a:solidFill>
+                  <a:schemeClr val="tx1"/>
+                </a:solidFill>
+                <a:latin typeface="Verdana" panose="020B0604030504040204" pitchFamily="34" charset="0"/>
+                <a:ea typeface="MS PGothic" panose="020B0600070205080204" pitchFamily="34" charset="-128"/>
+              </a:defRPr>
+            </a:lvl6pPr>
+            <a:lvl7pPr marL="2971800" indent="-228600" defTabSz="930275" eaLnBrk="0" fontAlgn="base" hangingPunct="0">
+              <a:spcBef>
+                <a:spcPct val="0"/>
+              </a:spcBef>
+              <a:spcAft>
+                <a:spcPct val="0"/>
+              </a:spcAft>
+              <a:defRPr>
+                <a:solidFill>
+                  <a:schemeClr val="tx1"/>
+                </a:solidFill>
+                <a:latin typeface="Verdana" panose="020B0604030504040204" pitchFamily="34" charset="0"/>
+                <a:ea typeface="MS PGothic" panose="020B0600070205080204" pitchFamily="34" charset="-128"/>
+              </a:defRPr>
+            </a:lvl7pPr>
+            <a:lvl8pPr marL="3429000" indent="-228600" defTabSz="930275" eaLnBrk="0" fontAlgn="base" hangingPunct="0">
+              <a:spcBef>
+                <a:spcPct val="0"/>
+              </a:spcBef>
+              <a:spcAft>
+                <a:spcPct val="0"/>
+              </a:spcAft>
+              <a:defRPr>
+                <a:solidFill>
+                  <a:schemeClr val="tx1"/>
+                </a:solidFill>
+                <a:latin typeface="Verdana" panose="020B0604030504040204" pitchFamily="34" charset="0"/>
+                <a:ea typeface="MS PGothic" panose="020B0600070205080204" pitchFamily="34" charset="-128"/>
+              </a:defRPr>
+            </a:lvl8pPr>
+            <a:lvl9pPr marL="3886200" indent="-228600" defTabSz="930275" eaLnBrk="0" fontAlgn="base" hangingPunct="0">
+              <a:spcBef>
+                <a:spcPct val="0"/>
+              </a:spcBef>
+              <a:spcAft>
+                <a:spcPct val="0"/>
+              </a:spcAft>
+              <a:defRPr>
+                <a:solidFill>
+                  <a:schemeClr val="tx1"/>
+                </a:solidFill>
+                <a:latin typeface="Verdana" panose="020B0604030504040204" pitchFamily="34" charset="0"/>
+                <a:ea typeface="MS PGothic" panose="020B0600070205080204" pitchFamily="34" charset="-128"/>
+              </a:defRPr>
+            </a:lvl9pPr>
+          </a:lstStyle>
+          <a:p>
+            <a:fld id="{962E0F78-D4D3-433B-8D40-C98934B24EFF}" type="slidenum">
+              <a:rPr lang="en-US" altLang="en-US">
+                <a:latin typeface="Times New Roman" panose="02020603050405020304" pitchFamily="18" charset="0"/>
+              </a:rPr>
+              <a:pPr/>
+              <a:t>38</a:t>
+            </a:fld>
+            <a:endParaRPr lang="en-US" altLang="en-US">
+              <a:latin typeface="Times New Roman" panose="02020603050405020304" pitchFamily="18" charset="0"/>
+            </a:endParaRPr>
+          </a:p>
+        </p:txBody>
+      </p:sp>
+      <p:sp>
+        <p:nvSpPr>
+          <p:cNvPr id="70659" name="Rectangle 2"/>
+          <p:cNvSpPr>
+            <a:spLocks noGrp="1" noRot="1" noChangeAspect="1" noChangeArrowheads="1" noTextEdit="1"/>
           </p:cNvSpPr>
           <p:nvPr>
             <p:ph type="sldImg"/>
           </p:nvPr>
         </p:nvSpPr>
-        <p:spPr/>
-      </p:sp>
-      <p:sp>
-        <p:nvSpPr>
-          <p:cNvPr id="3" name="Notes Placeholder 2"/>
-          <p:cNvSpPr>
-            <a:spLocks noGrp="1"/>
+        <p:spPr>
+          <a:ln/>
+        </p:spPr>
+      </p:sp>
+      <p:sp>
+        <p:nvSpPr>
+          <p:cNvPr id="70660" name="Rectangle 3"/>
+          <p:cNvSpPr>
+            <a:spLocks noGrp="1" noChangeArrowheads="1"/>
           </p:cNvSpPr>
           <p:nvPr>
             <p:ph type="body" idx="1"/>
           </p:nvPr>
         </p:nvSpPr>
-        <p:spPr/>
+        <p:spPr>
+          <a:noFill/>
+          <a:ln/>
+          <a:extLst>
+            <a:ext uri="{909E8E84-426E-40DD-AFC4-6F175D3DCCD1}">
+              <a14:hiddenFill xmlns:a14="http://schemas.microsoft.com/office/drawing/2010/main">
+                <a:solidFill>
+                  <a:srgbClr val="FFFFFF"/>
+                </a:solidFill>
+              </a14:hiddenFill>
+            </a:ext>
+            <a:ext uri="{91240B29-F687-4F45-9708-019B960494DF}">
+              <a14:hiddenLine xmlns:a14="http://schemas.microsoft.com/office/drawing/2010/main" w="9525">
+                <a:solidFill>
+                  <a:srgbClr val="000000"/>
+                </a:solidFill>
+                <a:miter lim="800000"/>
+                <a:headEnd/>
+                <a:tailEnd/>
+              </a14:hiddenLine>
+            </a:ext>
+          </a:extLst>
+        </p:spPr>
         <p:txBody>
           <a:bodyPr/>
           <a:lstStyle/>
           <a:p>
-            <a:endParaRPr lang="en-US"/>
-          </a:p>
-        </p:txBody>
-      </p:sp>
-      <p:sp>
-        <p:nvSpPr>
-          <p:cNvPr id="4" name="Slide Number Placeholder 3"/>
-          <p:cNvSpPr>
-            <a:spLocks noGrp="1"/>
-          </p:cNvSpPr>
-          <p:nvPr>
-            <p:ph type="sldNum" sz="quarter" idx="10"/>
-          </p:nvPr>
-        </p:nvSpPr>
-        <p:spPr/>
-        <p:txBody>
-          <a:bodyPr/>
-          <a:lstStyle/>
-          <a:p>
-            <a:fld id="{CAE0ABF5-7690-4623-B971-046A51D617CD}" type="slidenum">
-              <a:rPr lang="en-US" altLang="en-US" smtClean="0"/>
-              <a:pPr/>
-              <a:t>39</a:t>
-            </a:fld>
-            <a:endParaRPr lang="en-US" altLang="en-US"/>
+            <a:pPr eaLnBrk="1" hangingPunct="1"/>
+            <a:endParaRPr lang="en-US" altLang="en-US" dirty="0">
+              <a:latin typeface="Times New Roman" panose="02020603050405020304" pitchFamily="18" charset="0"/>
+            </a:endParaRPr>
           </a:p>
         </p:txBody>
       </p:sp>
     </p:spTree>
     <p:extLst>
       <p:ext uri="{BB962C8B-B14F-4D97-AF65-F5344CB8AC3E}">
-        <p14:creationId xmlns:p14="http://schemas.microsoft.com/office/powerpoint/2010/main" val="2059333206"/>
+        <p14:creationId xmlns:p14="http://schemas.microsoft.com/office/powerpoint/2010/main" val="3200878199"/>
       </p:ext>
     </p:extLst>
   </p:cSld>
@@ -5471,15 +5471,7 @@
           <a:bodyPr/>
           <a:lstStyle/>
           <a:p>
-            <a:r>
-              <a:rPr lang="en-US" dirty="0"/>
-              <a:t>do you agree with me that the size we cannot use in the block depends on how many blocks in total we have? This depends on</a:t>
-            </a:r>
-            <a:r>
-              <a:rPr lang="en-US" baseline="0" dirty="0"/>
-              <a:t> the size of the disk and the block size...</a:t>
-            </a:r>
-            <a:endParaRPr lang="en-US" dirty="0"/>
+            <a:endParaRPr lang="en-US"/>
           </a:p>
         </p:txBody>
       </p:sp>
@@ -5501,7 +5493,7 @@
             <a:fld id="{CAE0ABF5-7690-4623-B971-046A51D617CD}" type="slidenum">
               <a:rPr lang="en-US" altLang="en-US" smtClean="0"/>
               <a:pPr/>
-              <a:t>43</a:t>
+              <a:t>39</a:t>
             </a:fld>
             <a:endParaRPr lang="en-US" altLang="en-US"/>
           </a:p>
@@ -5510,7 +5502,7 @@
     </p:spTree>
     <p:extLst>
       <p:ext uri="{BB962C8B-B14F-4D97-AF65-F5344CB8AC3E}">
-        <p14:creationId xmlns:p14="http://schemas.microsoft.com/office/powerpoint/2010/main" val="1593687624"/>
+        <p14:creationId xmlns:p14="http://schemas.microsoft.com/office/powerpoint/2010/main" val="2059333206"/>
       </p:ext>
     </p:extLst>
   </p:cSld>
@@ -5539,212 +5531,63 @@
       </p:grpSpPr>
       <p:sp>
         <p:nvSpPr>
-          <p:cNvPr id="88066" name="Rectangle 7"/>
-          <p:cNvSpPr>
-            <a:spLocks noGrp="1" noChangeArrowheads="1"/>
-          </p:cNvSpPr>
-          <p:nvPr>
-            <p:ph type="sldNum" sz="quarter" idx="5"/>
-          </p:nvPr>
-        </p:nvSpPr>
-        <p:spPr>
-          <a:noFill/>
-          <a:ln/>
-          <a:extLst>
-            <a:ext uri="{909E8E84-426E-40DD-AFC4-6F175D3DCCD1}">
-              <a14:hiddenFill xmlns:a14="http://schemas.microsoft.com/office/drawing/2010/main">
-                <a:solidFill>
-                  <a:srgbClr val="FFFFFF"/>
-                </a:solidFill>
-              </a14:hiddenFill>
-            </a:ext>
-            <a:ext uri="{91240B29-F687-4F45-9708-019B960494DF}">
-              <a14:hiddenLine xmlns:a14="http://schemas.microsoft.com/office/drawing/2010/main" w="9525">
-                <a:solidFill>
-                  <a:srgbClr val="000000"/>
-                </a:solidFill>
-                <a:miter lim="800000"/>
-                <a:headEnd/>
-                <a:tailEnd/>
-              </a14:hiddenLine>
-            </a:ext>
-          </a:extLst>
-        </p:spPr>
+          <p:cNvPr id="2" name="Slide Image Placeholder 1"/>
+          <p:cNvSpPr>
+            <a:spLocks noGrp="1" noRot="1" noChangeAspect="1"/>
+          </p:cNvSpPr>
+          <p:nvPr>
+            <p:ph type="sldImg"/>
+          </p:nvPr>
+        </p:nvSpPr>
+        <p:spPr/>
+      </p:sp>
+      <p:sp>
+        <p:nvSpPr>
+          <p:cNvPr id="3" name="Notes Placeholder 2"/>
+          <p:cNvSpPr>
+            <a:spLocks noGrp="1"/>
+          </p:cNvSpPr>
+          <p:nvPr>
+            <p:ph type="body" idx="1"/>
+          </p:nvPr>
+        </p:nvSpPr>
+        <p:spPr/>
         <p:txBody>
           <a:bodyPr/>
-          <a:lstStyle>
-            <a:lvl1pPr defTabSz="923925">
-              <a:defRPr>
-                <a:solidFill>
-                  <a:schemeClr val="tx1"/>
-                </a:solidFill>
-                <a:latin typeface="Verdana" panose="020B0604030504040204" pitchFamily="34" charset="0"/>
-                <a:ea typeface="MS PGothic" panose="020B0600070205080204" pitchFamily="34" charset="-128"/>
-              </a:defRPr>
-            </a:lvl1pPr>
-            <a:lvl2pPr marL="742950" indent="-285750" defTabSz="923925">
-              <a:defRPr>
-                <a:solidFill>
-                  <a:schemeClr val="tx1"/>
-                </a:solidFill>
-                <a:latin typeface="Verdana" panose="020B0604030504040204" pitchFamily="34" charset="0"/>
-                <a:ea typeface="MS PGothic" panose="020B0600070205080204" pitchFamily="34" charset="-128"/>
-              </a:defRPr>
-            </a:lvl2pPr>
-            <a:lvl3pPr marL="1143000" indent="-228600" defTabSz="923925">
-              <a:defRPr>
-                <a:solidFill>
-                  <a:schemeClr val="tx1"/>
-                </a:solidFill>
-                <a:latin typeface="Verdana" panose="020B0604030504040204" pitchFamily="34" charset="0"/>
-                <a:ea typeface="MS PGothic" panose="020B0600070205080204" pitchFamily="34" charset="-128"/>
-              </a:defRPr>
-            </a:lvl3pPr>
-            <a:lvl4pPr marL="1600200" indent="-228600" defTabSz="923925">
-              <a:defRPr>
-                <a:solidFill>
-                  <a:schemeClr val="tx1"/>
-                </a:solidFill>
-                <a:latin typeface="Verdana" panose="020B0604030504040204" pitchFamily="34" charset="0"/>
-                <a:ea typeface="MS PGothic" panose="020B0600070205080204" pitchFamily="34" charset="-128"/>
-              </a:defRPr>
-            </a:lvl4pPr>
-            <a:lvl5pPr marL="2057400" indent="-228600" defTabSz="923925">
-              <a:defRPr>
-                <a:solidFill>
-                  <a:schemeClr val="tx1"/>
-                </a:solidFill>
-                <a:latin typeface="Verdana" panose="020B0604030504040204" pitchFamily="34" charset="0"/>
-                <a:ea typeface="MS PGothic" panose="020B0600070205080204" pitchFamily="34" charset="-128"/>
-              </a:defRPr>
-            </a:lvl5pPr>
-            <a:lvl6pPr marL="2514600" indent="-228600" defTabSz="923925" eaLnBrk="0" fontAlgn="base" hangingPunct="0">
-              <a:spcBef>
-                <a:spcPct val="0"/>
-              </a:spcBef>
-              <a:spcAft>
-                <a:spcPct val="0"/>
-              </a:spcAft>
-              <a:defRPr>
-                <a:solidFill>
-                  <a:schemeClr val="tx1"/>
-                </a:solidFill>
-                <a:latin typeface="Verdana" panose="020B0604030504040204" pitchFamily="34" charset="0"/>
-                <a:ea typeface="MS PGothic" panose="020B0600070205080204" pitchFamily="34" charset="-128"/>
-              </a:defRPr>
-            </a:lvl6pPr>
-            <a:lvl7pPr marL="2971800" indent="-228600" defTabSz="923925" eaLnBrk="0" fontAlgn="base" hangingPunct="0">
-              <a:spcBef>
-                <a:spcPct val="0"/>
-              </a:spcBef>
-              <a:spcAft>
-                <a:spcPct val="0"/>
-              </a:spcAft>
-              <a:defRPr>
-                <a:solidFill>
-                  <a:schemeClr val="tx1"/>
-                </a:solidFill>
-                <a:latin typeface="Verdana" panose="020B0604030504040204" pitchFamily="34" charset="0"/>
-                <a:ea typeface="MS PGothic" panose="020B0600070205080204" pitchFamily="34" charset="-128"/>
-              </a:defRPr>
-            </a:lvl7pPr>
-            <a:lvl8pPr marL="3429000" indent="-228600" defTabSz="923925" eaLnBrk="0" fontAlgn="base" hangingPunct="0">
-              <a:spcBef>
-                <a:spcPct val="0"/>
-              </a:spcBef>
-              <a:spcAft>
-                <a:spcPct val="0"/>
-              </a:spcAft>
-              <a:defRPr>
-                <a:solidFill>
-                  <a:schemeClr val="tx1"/>
-                </a:solidFill>
-                <a:latin typeface="Verdana" panose="020B0604030504040204" pitchFamily="34" charset="0"/>
-                <a:ea typeface="MS PGothic" panose="020B0600070205080204" pitchFamily="34" charset="-128"/>
-              </a:defRPr>
-            </a:lvl8pPr>
-            <a:lvl9pPr marL="3886200" indent="-228600" defTabSz="923925" eaLnBrk="0" fontAlgn="base" hangingPunct="0">
-              <a:spcBef>
-                <a:spcPct val="0"/>
-              </a:spcBef>
-              <a:spcAft>
-                <a:spcPct val="0"/>
-              </a:spcAft>
-              <a:defRPr>
-                <a:solidFill>
-                  <a:schemeClr val="tx1"/>
-                </a:solidFill>
-                <a:latin typeface="Verdana" panose="020B0604030504040204" pitchFamily="34" charset="0"/>
-                <a:ea typeface="MS PGothic" panose="020B0600070205080204" pitchFamily="34" charset="-128"/>
-              </a:defRPr>
-            </a:lvl9pPr>
-          </a:lstStyle>
-          <a:p>
-            <a:fld id="{94B1D134-850A-4179-8AB5-27314B993335}" type="slidenum">
-              <a:rPr lang="en-US" altLang="en-US">
-                <a:latin typeface="Times New Roman" panose="02020603050405020304" pitchFamily="18" charset="0"/>
-              </a:rPr>
+          <a:lstStyle/>
+          <a:p>
+            <a:r>
+              <a:rPr lang="en-US" dirty="0"/>
+              <a:t>do you agree with me that the size we cannot use in the block depends on how many blocks in total we have? This depends on</a:t>
+            </a:r>
+            <a:r>
+              <a:rPr lang="en-US" baseline="0" dirty="0"/>
+              <a:t> the size of the disk and the block size...</a:t>
+            </a:r>
+            <a:endParaRPr lang="en-US" dirty="0"/>
+          </a:p>
+        </p:txBody>
+      </p:sp>
+      <p:sp>
+        <p:nvSpPr>
+          <p:cNvPr id="4" name="Slide Number Placeholder 3"/>
+          <p:cNvSpPr>
+            <a:spLocks noGrp="1"/>
+          </p:cNvSpPr>
+          <p:nvPr>
+            <p:ph type="sldNum" sz="quarter" idx="10"/>
+          </p:nvPr>
+        </p:nvSpPr>
+        <p:spPr/>
+        <p:txBody>
+          <a:bodyPr/>
+          <a:lstStyle/>
+          <a:p>
+            <a:fld id="{CAE0ABF5-7690-4623-B971-046A51D617CD}" type="slidenum">
+              <a:rPr lang="en-US" altLang="en-US" smtClean="0"/>
               <a:pPr/>
-              <a:t>50</a:t>
+              <a:t>43</a:t>
             </a:fld>
-            <a:endParaRPr lang="en-US" altLang="en-US">
-              <a:latin typeface="Times New Roman" panose="02020603050405020304" pitchFamily="18" charset="0"/>
-            </a:endParaRPr>
-          </a:p>
-        </p:txBody>
-      </p:sp>
-      <p:sp>
-        <p:nvSpPr>
-          <p:cNvPr id="88067" name="Rectangle 2"/>
-          <p:cNvSpPr>
-            <a:spLocks noGrp="1" noRot="1" noChangeAspect="1" noChangeArrowheads="1" noTextEdit="1"/>
-          </p:cNvSpPr>
-          <p:nvPr>
-            <p:ph type="sldImg"/>
-          </p:nvPr>
-        </p:nvSpPr>
-        <p:spPr>
-          <a:ln/>
-        </p:spPr>
-      </p:sp>
-      <p:sp>
-        <p:nvSpPr>
-          <p:cNvPr id="88068" name="Rectangle 3"/>
-          <p:cNvSpPr>
-            <a:spLocks noGrp="1" noChangeArrowheads="1"/>
-          </p:cNvSpPr>
-          <p:nvPr>
-            <p:ph type="body" idx="1"/>
-          </p:nvPr>
-        </p:nvSpPr>
-        <p:spPr>
-          <a:noFill/>
-          <a:ln/>
-          <a:extLst>
-            <a:ext uri="{909E8E84-426E-40DD-AFC4-6F175D3DCCD1}">
-              <a14:hiddenFill xmlns:a14="http://schemas.microsoft.com/office/drawing/2010/main">
-                <a:solidFill>
-                  <a:srgbClr val="FFFFFF"/>
-                </a:solidFill>
-              </a14:hiddenFill>
-            </a:ext>
-            <a:ext uri="{91240B29-F687-4F45-9708-019B960494DF}">
-              <a14:hiddenLine xmlns:a14="http://schemas.microsoft.com/office/drawing/2010/main" w="9525">
-                <a:solidFill>
-                  <a:srgbClr val="000000"/>
-                </a:solidFill>
-                <a:miter lim="800000"/>
-                <a:headEnd/>
-                <a:tailEnd/>
-              </a14:hiddenLine>
-            </a:ext>
-          </a:extLst>
-        </p:spPr>
-        <p:txBody>
-          <a:bodyPr/>
-          <a:lstStyle/>
-          <a:p>
-            <a:pPr eaLnBrk="1" hangingPunct="1"/>
             <a:endParaRPr lang="en-US" altLang="en-US"/>
           </a:p>
         </p:txBody>
@@ -5752,7 +5595,7 @@
     </p:spTree>
     <p:extLst>
       <p:ext uri="{BB962C8B-B14F-4D97-AF65-F5344CB8AC3E}">
-        <p14:creationId xmlns:p14="http://schemas.microsoft.com/office/powerpoint/2010/main" val="1600709815"/>
+        <p14:creationId xmlns:p14="http://schemas.microsoft.com/office/powerpoint/2010/main" val="1593687624"/>
       </p:ext>
     </p:extLst>
   </p:cSld>
@@ -5781,7 +5624,7 @@
       </p:grpSpPr>
       <p:sp>
         <p:nvSpPr>
-          <p:cNvPr id="89090" name="Rectangle 7"/>
+          <p:cNvPr id="88066" name="Rectangle 7"/>
           <p:cNvSpPr>
             <a:spLocks noGrp="1" noChangeArrowheads="1"/>
           </p:cNvSpPr>
@@ -5922,12 +5765,12 @@
             </a:lvl9pPr>
           </a:lstStyle>
           <a:p>
-            <a:fld id="{6E940149-BF14-45B4-82CA-B38D8EAF2464}" type="slidenum">
+            <a:fld id="{94B1D134-850A-4179-8AB5-27314B993335}" type="slidenum">
               <a:rPr lang="en-US" altLang="en-US">
                 <a:latin typeface="Times New Roman" panose="02020603050405020304" pitchFamily="18" charset="0"/>
               </a:rPr>
               <a:pPr/>
-              <a:t>51</a:t>
+              <a:t>50</a:t>
             </a:fld>
             <a:endParaRPr lang="en-US" altLang="en-US">
               <a:latin typeface="Times New Roman" panose="02020603050405020304" pitchFamily="18" charset="0"/>
@@ -5937,7 +5780,7 @@
       </p:sp>
       <p:sp>
         <p:nvSpPr>
-          <p:cNvPr id="89091" name="Rectangle 2"/>
+          <p:cNvPr id="88067" name="Rectangle 2"/>
           <p:cNvSpPr>
             <a:spLocks noGrp="1" noRot="1" noChangeAspect="1" noChangeArrowheads="1" noTextEdit="1"/>
           </p:cNvSpPr>
@@ -5951,7 +5794,7 @@
       </p:sp>
       <p:sp>
         <p:nvSpPr>
-          <p:cNvPr id="89092" name="Rectangle 3"/>
+          <p:cNvPr id="88068" name="Rectangle 3"/>
           <p:cNvSpPr>
             <a:spLocks noGrp="1" noChangeArrowheads="1"/>
           </p:cNvSpPr>
@@ -5994,7 +5837,7 @@
     </p:spTree>
     <p:extLst>
       <p:ext uri="{BB962C8B-B14F-4D97-AF65-F5344CB8AC3E}">
-        <p14:creationId xmlns:p14="http://schemas.microsoft.com/office/powerpoint/2010/main" val="3566095115"/>
+        <p14:creationId xmlns:p14="http://schemas.microsoft.com/office/powerpoint/2010/main" val="1600709815"/>
       </p:ext>
     </p:extLst>
   </p:cSld>
@@ -6023,7 +5866,7 @@
       </p:grpSpPr>
       <p:sp>
         <p:nvSpPr>
-          <p:cNvPr id="90114" name="Rectangle 7"/>
+          <p:cNvPr id="89090" name="Rectangle 7"/>
           <p:cNvSpPr>
             <a:spLocks noGrp="1" noChangeArrowheads="1"/>
           </p:cNvSpPr>
@@ -6164,12 +6007,12 @@
             </a:lvl9pPr>
           </a:lstStyle>
           <a:p>
-            <a:fld id="{6BCDB1EE-CC89-4FB6-A722-3BDC79779409}" type="slidenum">
+            <a:fld id="{6E940149-BF14-45B4-82CA-B38D8EAF2464}" type="slidenum">
               <a:rPr lang="en-US" altLang="en-US">
                 <a:latin typeface="Times New Roman" panose="02020603050405020304" pitchFamily="18" charset="0"/>
               </a:rPr>
               <a:pPr/>
-              <a:t>52</a:t>
+              <a:t>51</a:t>
             </a:fld>
             <a:endParaRPr lang="en-US" altLang="en-US">
               <a:latin typeface="Times New Roman" panose="02020603050405020304" pitchFamily="18" charset="0"/>
@@ -6179,7 +6022,7 @@
       </p:sp>
       <p:sp>
         <p:nvSpPr>
-          <p:cNvPr id="90115" name="Rectangle 2"/>
+          <p:cNvPr id="89091" name="Rectangle 2"/>
           <p:cNvSpPr>
             <a:spLocks noGrp="1" noRot="1" noChangeAspect="1" noChangeArrowheads="1" noTextEdit="1"/>
           </p:cNvSpPr>
@@ -6193,7 +6036,7 @@
       </p:sp>
       <p:sp>
         <p:nvSpPr>
-          <p:cNvPr id="90116" name="Rectangle 3"/>
+          <p:cNvPr id="89092" name="Rectangle 3"/>
           <p:cNvSpPr>
             <a:spLocks noGrp="1" noChangeArrowheads="1"/>
           </p:cNvSpPr>
@@ -6236,7 +6079,7 @@
     </p:spTree>
     <p:extLst>
       <p:ext uri="{BB962C8B-B14F-4D97-AF65-F5344CB8AC3E}">
-        <p14:creationId xmlns:p14="http://schemas.microsoft.com/office/powerpoint/2010/main" val="4073403759"/>
+        <p14:creationId xmlns:p14="http://schemas.microsoft.com/office/powerpoint/2010/main" val="3566095115"/>
       </p:ext>
     </p:extLst>
   </p:cSld>
@@ -6265,7 +6108,7 @@
       </p:grpSpPr>
       <p:sp>
         <p:nvSpPr>
-          <p:cNvPr id="91138" name="Rectangle 7"/>
+          <p:cNvPr id="90114" name="Rectangle 7"/>
           <p:cNvSpPr>
             <a:spLocks noGrp="1" noChangeArrowheads="1"/>
           </p:cNvSpPr>
@@ -6406,12 +6249,12 @@
             </a:lvl9pPr>
           </a:lstStyle>
           <a:p>
-            <a:fld id="{A3F1B1A2-C3C1-4054-A7B9-667F21ADB782}" type="slidenum">
+            <a:fld id="{6BCDB1EE-CC89-4FB6-A722-3BDC79779409}" type="slidenum">
               <a:rPr lang="en-US" altLang="en-US">
                 <a:latin typeface="Times New Roman" panose="02020603050405020304" pitchFamily="18" charset="0"/>
               </a:rPr>
               <a:pPr/>
-              <a:t>53</a:t>
+              <a:t>52</a:t>
             </a:fld>
             <a:endParaRPr lang="en-US" altLang="en-US">
               <a:latin typeface="Times New Roman" panose="02020603050405020304" pitchFamily="18" charset="0"/>
@@ -6421,7 +6264,7 @@
       </p:sp>
       <p:sp>
         <p:nvSpPr>
-          <p:cNvPr id="91139" name="Rectangle 2"/>
+          <p:cNvPr id="90115" name="Rectangle 2"/>
           <p:cNvSpPr>
             <a:spLocks noGrp="1" noRot="1" noChangeAspect="1" noChangeArrowheads="1" noTextEdit="1"/>
           </p:cNvSpPr>
@@ -6435,7 +6278,7 @@
       </p:sp>
       <p:sp>
         <p:nvSpPr>
-          <p:cNvPr id="91140" name="Rectangle 3"/>
+          <p:cNvPr id="90116" name="Rectangle 3"/>
           <p:cNvSpPr>
             <a:spLocks noGrp="1" noChangeArrowheads="1"/>
           </p:cNvSpPr>
@@ -6478,7 +6321,7 @@
     </p:spTree>
     <p:extLst>
       <p:ext uri="{BB962C8B-B14F-4D97-AF65-F5344CB8AC3E}">
-        <p14:creationId xmlns:p14="http://schemas.microsoft.com/office/powerpoint/2010/main" val="1322191936"/>
+        <p14:creationId xmlns:p14="http://schemas.microsoft.com/office/powerpoint/2010/main" val="4073403759"/>
       </p:ext>
     </p:extLst>
   </p:cSld>
@@ -6507,58 +6350,212 @@
       </p:grpSpPr>
       <p:sp>
         <p:nvSpPr>
-          <p:cNvPr id="2" name="Slide Image Placeholder 1"/>
-          <p:cNvSpPr>
-            <a:spLocks noGrp="1" noRot="1" noChangeAspect="1"/>
+          <p:cNvPr id="91138" name="Rectangle 7"/>
+          <p:cNvSpPr>
+            <a:spLocks noGrp="1" noChangeArrowheads="1"/>
+          </p:cNvSpPr>
+          <p:nvPr>
+            <p:ph type="sldNum" sz="quarter" idx="5"/>
+          </p:nvPr>
+        </p:nvSpPr>
+        <p:spPr>
+          <a:noFill/>
+          <a:ln/>
+          <a:extLst>
+            <a:ext uri="{909E8E84-426E-40DD-AFC4-6F175D3DCCD1}">
+              <a14:hiddenFill xmlns:a14="http://schemas.microsoft.com/office/drawing/2010/main">
+                <a:solidFill>
+                  <a:srgbClr val="FFFFFF"/>
+                </a:solidFill>
+              </a14:hiddenFill>
+            </a:ext>
+            <a:ext uri="{91240B29-F687-4F45-9708-019B960494DF}">
+              <a14:hiddenLine xmlns:a14="http://schemas.microsoft.com/office/drawing/2010/main" w="9525">
+                <a:solidFill>
+                  <a:srgbClr val="000000"/>
+                </a:solidFill>
+                <a:miter lim="800000"/>
+                <a:headEnd/>
+                <a:tailEnd/>
+              </a14:hiddenLine>
+            </a:ext>
+          </a:extLst>
+        </p:spPr>
+        <p:txBody>
+          <a:bodyPr/>
+          <a:lstStyle>
+            <a:lvl1pPr defTabSz="923925">
+              <a:defRPr>
+                <a:solidFill>
+                  <a:schemeClr val="tx1"/>
+                </a:solidFill>
+                <a:latin typeface="Verdana" panose="020B0604030504040204" pitchFamily="34" charset="0"/>
+                <a:ea typeface="MS PGothic" panose="020B0600070205080204" pitchFamily="34" charset="-128"/>
+              </a:defRPr>
+            </a:lvl1pPr>
+            <a:lvl2pPr marL="742950" indent="-285750" defTabSz="923925">
+              <a:defRPr>
+                <a:solidFill>
+                  <a:schemeClr val="tx1"/>
+                </a:solidFill>
+                <a:latin typeface="Verdana" panose="020B0604030504040204" pitchFamily="34" charset="0"/>
+                <a:ea typeface="MS PGothic" panose="020B0600070205080204" pitchFamily="34" charset="-128"/>
+              </a:defRPr>
+            </a:lvl2pPr>
+            <a:lvl3pPr marL="1143000" indent="-228600" defTabSz="923925">
+              <a:defRPr>
+                <a:solidFill>
+                  <a:schemeClr val="tx1"/>
+                </a:solidFill>
+                <a:latin typeface="Verdana" panose="020B0604030504040204" pitchFamily="34" charset="0"/>
+                <a:ea typeface="MS PGothic" panose="020B0600070205080204" pitchFamily="34" charset="-128"/>
+              </a:defRPr>
+            </a:lvl3pPr>
+            <a:lvl4pPr marL="1600200" indent="-228600" defTabSz="923925">
+              <a:defRPr>
+                <a:solidFill>
+                  <a:schemeClr val="tx1"/>
+                </a:solidFill>
+                <a:latin typeface="Verdana" panose="020B0604030504040204" pitchFamily="34" charset="0"/>
+                <a:ea typeface="MS PGothic" panose="020B0600070205080204" pitchFamily="34" charset="-128"/>
+              </a:defRPr>
+            </a:lvl4pPr>
+            <a:lvl5pPr marL="2057400" indent="-228600" defTabSz="923925">
+              <a:defRPr>
+                <a:solidFill>
+                  <a:schemeClr val="tx1"/>
+                </a:solidFill>
+                <a:latin typeface="Verdana" panose="020B0604030504040204" pitchFamily="34" charset="0"/>
+                <a:ea typeface="MS PGothic" panose="020B0600070205080204" pitchFamily="34" charset="-128"/>
+              </a:defRPr>
+            </a:lvl5pPr>
+            <a:lvl6pPr marL="2514600" indent="-228600" defTabSz="923925" eaLnBrk="0" fontAlgn="base" hangingPunct="0">
+              <a:spcBef>
+                <a:spcPct val="0"/>
+              </a:spcBef>
+              <a:spcAft>
+                <a:spcPct val="0"/>
+              </a:spcAft>
+              <a:defRPr>
+                <a:solidFill>
+                  <a:schemeClr val="tx1"/>
+                </a:solidFill>
+                <a:latin typeface="Verdana" panose="020B0604030504040204" pitchFamily="34" charset="0"/>
+                <a:ea typeface="MS PGothic" panose="020B0600070205080204" pitchFamily="34" charset="-128"/>
+              </a:defRPr>
+            </a:lvl6pPr>
+            <a:lvl7pPr marL="2971800" indent="-228600" defTabSz="923925" eaLnBrk="0" fontAlgn="base" hangingPunct="0">
+              <a:spcBef>
+                <a:spcPct val="0"/>
+              </a:spcBef>
+              <a:spcAft>
+                <a:spcPct val="0"/>
+              </a:spcAft>
+              <a:defRPr>
+                <a:solidFill>
+                  <a:schemeClr val="tx1"/>
+                </a:solidFill>
+                <a:latin typeface="Verdana" panose="020B0604030504040204" pitchFamily="34" charset="0"/>
+                <a:ea typeface="MS PGothic" panose="020B0600070205080204" pitchFamily="34" charset="-128"/>
+              </a:defRPr>
+            </a:lvl7pPr>
+            <a:lvl8pPr marL="3429000" indent="-228600" defTabSz="923925" eaLnBrk="0" fontAlgn="base" hangingPunct="0">
+              <a:spcBef>
+                <a:spcPct val="0"/>
+              </a:spcBef>
+              <a:spcAft>
+                <a:spcPct val="0"/>
+              </a:spcAft>
+              <a:defRPr>
+                <a:solidFill>
+                  <a:schemeClr val="tx1"/>
+                </a:solidFill>
+                <a:latin typeface="Verdana" panose="020B0604030504040204" pitchFamily="34" charset="0"/>
+                <a:ea typeface="MS PGothic" panose="020B0600070205080204" pitchFamily="34" charset="-128"/>
+              </a:defRPr>
+            </a:lvl8pPr>
+            <a:lvl9pPr marL="3886200" indent="-228600" defTabSz="923925" eaLnBrk="0" fontAlgn="base" hangingPunct="0">
+              <a:spcBef>
+                <a:spcPct val="0"/>
+              </a:spcBef>
+              <a:spcAft>
+                <a:spcPct val="0"/>
+              </a:spcAft>
+              <a:defRPr>
+                <a:solidFill>
+                  <a:schemeClr val="tx1"/>
+                </a:solidFill>
+                <a:latin typeface="Verdana" panose="020B0604030504040204" pitchFamily="34" charset="0"/>
+                <a:ea typeface="MS PGothic" panose="020B0600070205080204" pitchFamily="34" charset="-128"/>
+              </a:defRPr>
+            </a:lvl9pPr>
+          </a:lstStyle>
+          <a:p>
+            <a:fld id="{A3F1B1A2-C3C1-4054-A7B9-667F21ADB782}" type="slidenum">
+              <a:rPr lang="en-US" altLang="en-US">
+                <a:latin typeface="Times New Roman" panose="02020603050405020304" pitchFamily="18" charset="0"/>
+              </a:rPr>
+              <a:pPr/>
+              <a:t>53</a:t>
+            </a:fld>
+            <a:endParaRPr lang="en-US" altLang="en-US">
+              <a:latin typeface="Times New Roman" panose="02020603050405020304" pitchFamily="18" charset="0"/>
+            </a:endParaRPr>
+          </a:p>
+        </p:txBody>
+      </p:sp>
+      <p:sp>
+        <p:nvSpPr>
+          <p:cNvPr id="91139" name="Rectangle 2"/>
+          <p:cNvSpPr>
+            <a:spLocks noGrp="1" noRot="1" noChangeAspect="1" noChangeArrowheads="1" noTextEdit="1"/>
           </p:cNvSpPr>
           <p:nvPr>
             <p:ph type="sldImg"/>
           </p:nvPr>
         </p:nvSpPr>
-        <p:spPr/>
-      </p:sp>
-      <p:sp>
-        <p:nvSpPr>
-          <p:cNvPr id="3" name="Notes Placeholder 2"/>
-          <p:cNvSpPr>
-            <a:spLocks noGrp="1"/>
+        <p:spPr>
+          <a:ln/>
+        </p:spPr>
+      </p:sp>
+      <p:sp>
+        <p:nvSpPr>
+          <p:cNvPr id="91140" name="Rectangle 3"/>
+          <p:cNvSpPr>
+            <a:spLocks noGrp="1" noChangeArrowheads="1"/>
           </p:cNvSpPr>
           <p:nvPr>
             <p:ph type="body" idx="1"/>
           </p:nvPr>
         </p:nvSpPr>
-        <p:spPr/>
+        <p:spPr>
+          <a:noFill/>
+          <a:ln/>
+          <a:extLst>
+            <a:ext uri="{909E8E84-426E-40DD-AFC4-6F175D3DCCD1}">
+              <a14:hiddenFill xmlns:a14="http://schemas.microsoft.com/office/drawing/2010/main">
+                <a:solidFill>
+                  <a:srgbClr val="FFFFFF"/>
+                </a:solidFill>
+              </a14:hiddenFill>
+            </a:ext>
+            <a:ext uri="{91240B29-F687-4F45-9708-019B960494DF}">
+              <a14:hiddenLine xmlns:a14="http://schemas.microsoft.com/office/drawing/2010/main" w="9525">
+                <a:solidFill>
+                  <a:srgbClr val="000000"/>
+                </a:solidFill>
+                <a:miter lim="800000"/>
+                <a:headEnd/>
+                <a:tailEnd/>
+              </a14:hiddenLine>
+            </a:ext>
+          </a:extLst>
+        </p:spPr>
         <p:txBody>
           <a:bodyPr/>
           <a:lstStyle/>
           <a:p>
-            <a:r>
-              <a:rPr lang="en-US" dirty="0"/>
-              <a:t>1</a:t>
-            </a:r>
-          </a:p>
-        </p:txBody>
-      </p:sp>
-      <p:sp>
-        <p:nvSpPr>
-          <p:cNvPr id="4" name="Slide Number Placeholder 3"/>
-          <p:cNvSpPr>
-            <a:spLocks noGrp="1"/>
-          </p:cNvSpPr>
-          <p:nvPr>
-            <p:ph type="sldNum" sz="quarter" idx="5"/>
-          </p:nvPr>
-        </p:nvSpPr>
-        <p:spPr/>
-        <p:txBody>
-          <a:bodyPr/>
-          <a:lstStyle/>
-          <a:p>
-            <a:fld id="{CAE0ABF5-7690-4623-B971-046A51D617CD}" type="slidenum">
-              <a:rPr lang="en-US" altLang="en-US" smtClean="0"/>
-              <a:pPr/>
-              <a:t>55</a:t>
-            </a:fld>
+            <a:pPr eaLnBrk="1" hangingPunct="1"/>
             <a:endParaRPr lang="en-US" altLang="en-US"/>
           </a:p>
         </p:txBody>
@@ -6566,7 +6563,7 @@
     </p:spTree>
     <p:extLst>
       <p:ext uri="{BB962C8B-B14F-4D97-AF65-F5344CB8AC3E}">
-        <p14:creationId xmlns:p14="http://schemas.microsoft.com/office/powerpoint/2010/main" val="1563920115"/>
+        <p14:creationId xmlns:p14="http://schemas.microsoft.com/office/powerpoint/2010/main" val="1322191936"/>
       </p:ext>
     </p:extLst>
   </p:cSld>
@@ -6622,7 +6619,7 @@
           <a:p>
             <a:r>
               <a:rPr lang="en-US" dirty="0"/>
-              <a:t>2</a:t>
+              <a:t>1</a:t>
             </a:r>
           </a:p>
         </p:txBody>
@@ -6645,7 +6642,7 @@
             <a:fld id="{CAE0ABF5-7690-4623-B971-046A51D617CD}" type="slidenum">
               <a:rPr lang="en-US" altLang="en-US" smtClean="0"/>
               <a:pPr/>
-              <a:t>56</a:t>
+              <a:t>55</a:t>
             </a:fld>
             <a:endParaRPr lang="en-US" altLang="en-US"/>
           </a:p>
@@ -6654,7 +6651,7 @@
     </p:spTree>
     <p:extLst>
       <p:ext uri="{BB962C8B-B14F-4D97-AF65-F5344CB8AC3E}">
-        <p14:creationId xmlns:p14="http://schemas.microsoft.com/office/powerpoint/2010/main" val="20567884"/>
+        <p14:creationId xmlns:p14="http://schemas.microsoft.com/office/powerpoint/2010/main" val="1563920115"/>
       </p:ext>
     </p:extLst>
   </p:cSld>
@@ -6710,7 +6707,7 @@
           <a:p>
             <a:r>
               <a:rPr lang="en-US" dirty="0"/>
-              <a:t>3 4</a:t>
+              <a:t>2</a:t>
             </a:r>
           </a:p>
         </p:txBody>
@@ -6733,7 +6730,7 @@
             <a:fld id="{CAE0ABF5-7690-4623-B971-046A51D617CD}" type="slidenum">
               <a:rPr lang="en-US" altLang="en-US" smtClean="0"/>
               <a:pPr/>
-              <a:t>57</a:t>
+              <a:t>56</a:t>
             </a:fld>
             <a:endParaRPr lang="en-US" altLang="en-US"/>
           </a:p>
@@ -6742,7 +6739,7 @@
     </p:spTree>
     <p:extLst>
       <p:ext uri="{BB962C8B-B14F-4D97-AF65-F5344CB8AC3E}">
-        <p14:creationId xmlns:p14="http://schemas.microsoft.com/office/powerpoint/2010/main" val="3814815025"/>
+        <p14:creationId xmlns:p14="http://schemas.microsoft.com/office/powerpoint/2010/main" val="20567884"/>
       </p:ext>
     </p:extLst>
   </p:cSld>
@@ -7040,7 +7037,7 @@
           <a:p>
             <a:r>
               <a:rPr lang="en-US" dirty="0"/>
-              <a:t>1</a:t>
+              <a:t>3 4</a:t>
             </a:r>
           </a:p>
         </p:txBody>
@@ -7063,7 +7060,7 @@
             <a:fld id="{CAE0ABF5-7690-4623-B971-046A51D617CD}" type="slidenum">
               <a:rPr lang="en-US" altLang="en-US" smtClean="0"/>
               <a:pPr/>
-              <a:t>58</a:t>
+              <a:t>57</a:t>
             </a:fld>
             <a:endParaRPr lang="en-US" altLang="en-US"/>
           </a:p>
@@ -7072,7 +7069,7 @@
     </p:spTree>
     <p:extLst>
       <p:ext uri="{BB962C8B-B14F-4D97-AF65-F5344CB8AC3E}">
-        <p14:creationId xmlns:p14="http://schemas.microsoft.com/office/powerpoint/2010/main" val="1058236479"/>
+        <p14:creationId xmlns:p14="http://schemas.microsoft.com/office/powerpoint/2010/main" val="3814815025"/>
       </p:ext>
     </p:extLst>
   </p:cSld>
@@ -7128,7 +7125,7 @@
           <a:p>
             <a:r>
               <a:rPr lang="en-US" dirty="0"/>
-              <a:t>3</a:t>
+              <a:t>1</a:t>
             </a:r>
           </a:p>
         </p:txBody>
@@ -7151,7 +7148,7 @@
             <a:fld id="{CAE0ABF5-7690-4623-B971-046A51D617CD}" type="slidenum">
               <a:rPr lang="en-US" altLang="en-US" smtClean="0"/>
               <a:pPr/>
-              <a:t>59</a:t>
+              <a:t>58</a:t>
             </a:fld>
             <a:endParaRPr lang="en-US" altLang="en-US"/>
           </a:p>
@@ -7160,7 +7157,7 @@
     </p:spTree>
     <p:extLst>
       <p:ext uri="{BB962C8B-B14F-4D97-AF65-F5344CB8AC3E}">
-        <p14:creationId xmlns:p14="http://schemas.microsoft.com/office/powerpoint/2010/main" val="1226731704"/>
+        <p14:creationId xmlns:p14="http://schemas.microsoft.com/office/powerpoint/2010/main" val="1058236479"/>
       </p:ext>
     </p:extLst>
   </p:cSld>
@@ -7239,7 +7236,7 @@
             <a:fld id="{CAE0ABF5-7690-4623-B971-046A51D617CD}" type="slidenum">
               <a:rPr lang="en-US" altLang="en-US" smtClean="0"/>
               <a:pPr/>
-              <a:t>60</a:t>
+              <a:t>59</a:t>
             </a:fld>
             <a:endParaRPr lang="en-US" altLang="en-US"/>
           </a:p>
@@ -7248,7 +7245,7 @@
     </p:spTree>
     <p:extLst>
       <p:ext uri="{BB962C8B-B14F-4D97-AF65-F5344CB8AC3E}">
-        <p14:creationId xmlns:p14="http://schemas.microsoft.com/office/powerpoint/2010/main" val="1323319121"/>
+        <p14:creationId xmlns:p14="http://schemas.microsoft.com/office/powerpoint/2010/main" val="1226731704"/>
       </p:ext>
     </p:extLst>
   </p:cSld>
@@ -7302,33 +7299,9 @@
           <a:bodyPr/>
           <a:lstStyle/>
           <a:p>
-            <a:pPr marL="0" marR="0" lvl="0" indent="0" algn="l" defTabSz="914400" rtl="0" eaLnBrk="0" fontAlgn="base" latinLnBrk="0" hangingPunct="0">
-              <a:lnSpc>
-                <a:spcPct val="100000"/>
-              </a:lnSpc>
-              <a:spcBef>
-                <a:spcPct val="30000"/>
-              </a:spcBef>
-              <a:spcAft>
-                <a:spcPct val="0"/>
-              </a:spcAft>
-              <a:buClrTx/>
-              <a:buSzTx/>
-              <a:buFontTx/>
-              <a:buNone/>
-              <a:tabLst/>
-              <a:defRPr/>
-            </a:pPr>
-            <a:r>
-              <a:rPr lang="en-US" sz="1200" dirty="0"/>
-              <a:t>(12 * 8 /KB/) + (2048 * 8 /KB) + (2048 * 2048 * 8 /KB/) </a:t>
-            </a:r>
-            <a:br>
-              <a:rPr lang="en-US" sz="1200" dirty="0"/>
-            </a:br>
-            <a:r>
-              <a:rPr lang="en-US" sz="1200" dirty="0"/>
-              <a:t>+ (2048 * 2048 * 2048 * 8 /KB) = 64 terabytes</a:t>
+            <a:r>
+              <a:rPr lang="en-US" dirty="0"/>
+              <a:t>3</a:t>
             </a:r>
           </a:p>
         </p:txBody>
@@ -7351,7 +7324,7 @@
             <a:fld id="{CAE0ABF5-7690-4623-B971-046A51D617CD}" type="slidenum">
               <a:rPr lang="en-US" altLang="en-US" smtClean="0"/>
               <a:pPr/>
-              <a:t>61</a:t>
+              <a:t>60</a:t>
             </a:fld>
             <a:endParaRPr lang="en-US" altLang="en-US"/>
           </a:p>
@@ -7360,7 +7333,7 @@
     </p:spTree>
     <p:extLst>
       <p:ext uri="{BB962C8B-B14F-4D97-AF65-F5344CB8AC3E}">
-        <p14:creationId xmlns:p14="http://schemas.microsoft.com/office/powerpoint/2010/main" val="2705930493"/>
+        <p14:creationId xmlns:p14="http://schemas.microsoft.com/office/powerpoint/2010/main" val="1323319121"/>
       </p:ext>
     </p:extLst>
   </p:cSld>
@@ -7433,6 +7406,118 @@
             </a:pPr>
             <a:r>
               <a:rPr lang="en-US" sz="1200" dirty="0"/>
+              <a:t>(12 * 8 /KB/) + (2048 * 8 /KB) + (2048 * 2048 * 8 /KB/) </a:t>
+            </a:r>
+            <a:br>
+              <a:rPr lang="en-US" sz="1200" dirty="0"/>
+            </a:br>
+            <a:r>
+              <a:rPr lang="en-US" sz="1200" dirty="0"/>
+              <a:t>+ (2048 * 2048 * 2048 * 8 /KB) = 64 terabytes</a:t>
+            </a:r>
+          </a:p>
+        </p:txBody>
+      </p:sp>
+      <p:sp>
+        <p:nvSpPr>
+          <p:cNvPr id="4" name="Slide Number Placeholder 3"/>
+          <p:cNvSpPr>
+            <a:spLocks noGrp="1"/>
+          </p:cNvSpPr>
+          <p:nvPr>
+            <p:ph type="sldNum" sz="quarter" idx="5"/>
+          </p:nvPr>
+        </p:nvSpPr>
+        <p:spPr/>
+        <p:txBody>
+          <a:bodyPr/>
+          <a:lstStyle/>
+          <a:p>
+            <a:fld id="{CAE0ABF5-7690-4623-B971-046A51D617CD}" type="slidenum">
+              <a:rPr lang="en-US" altLang="en-US" smtClean="0"/>
+              <a:pPr/>
+              <a:t>61</a:t>
+            </a:fld>
+            <a:endParaRPr lang="en-US" altLang="en-US"/>
+          </a:p>
+        </p:txBody>
+      </p:sp>
+    </p:spTree>
+    <p:extLst>
+      <p:ext uri="{BB962C8B-B14F-4D97-AF65-F5344CB8AC3E}">
+        <p14:creationId xmlns:p14="http://schemas.microsoft.com/office/powerpoint/2010/main" val="2705930493"/>
+      </p:ext>
+    </p:extLst>
+  </p:cSld>
+  <p:clrMapOvr>
+    <a:masterClrMapping/>
+  </p:clrMapOvr>
+</p:notes>
+</file>
+
+<file path=ppt/notesSlides/notesSlide45.xml><?xml version="1.0" encoding="utf-8"?>
+<p:notes xmlns:a="http://schemas.openxmlformats.org/drawingml/2006/main" xmlns:r="http://schemas.openxmlformats.org/officeDocument/2006/relationships" xmlns:p="http://schemas.openxmlformats.org/presentationml/2006/main">
+  <p:cSld>
+    <p:spTree>
+      <p:nvGrpSpPr>
+        <p:cNvPr id="1" name=""/>
+        <p:cNvGrpSpPr/>
+        <p:nvPr/>
+      </p:nvGrpSpPr>
+      <p:grpSpPr>
+        <a:xfrm>
+          <a:off x="0" y="0"/>
+          <a:ext cx="0" cy="0"/>
+          <a:chOff x="0" y="0"/>
+          <a:chExt cx="0" cy="0"/>
+        </a:xfrm>
+      </p:grpSpPr>
+      <p:sp>
+        <p:nvSpPr>
+          <p:cNvPr id="2" name="Slide Image Placeholder 1"/>
+          <p:cNvSpPr>
+            <a:spLocks noGrp="1" noRot="1" noChangeAspect="1"/>
+          </p:cNvSpPr>
+          <p:nvPr>
+            <p:ph type="sldImg"/>
+          </p:nvPr>
+        </p:nvSpPr>
+        <p:spPr/>
+      </p:sp>
+      <p:sp>
+        <p:nvSpPr>
+          <p:cNvPr id="3" name="Notes Placeholder 2"/>
+          <p:cNvSpPr>
+            <a:spLocks noGrp="1"/>
+          </p:cNvSpPr>
+          <p:nvPr>
+            <p:ph type="body" idx="1"/>
+          </p:nvPr>
+        </p:nvSpPr>
+        <p:spPr/>
+        <p:txBody>
+          <a:bodyPr/>
+          <a:lstStyle/>
+          <a:p>
+            <a:pPr marL="0" marR="0" lvl="0" indent="0" algn="l" defTabSz="914400" rtl="0" eaLnBrk="0" fontAlgn="base" latinLnBrk="0" hangingPunct="0">
+              <a:lnSpc>
+                <a:spcPct val="100000"/>
+              </a:lnSpc>
+              <a:spcBef>
+                <a:spcPct val="30000"/>
+              </a:spcBef>
+              <a:spcAft>
+                <a:spcPct val="0"/>
+              </a:spcAft>
+              <a:buClrTx/>
+              <a:buSzTx/>
+              <a:buFontTx/>
+              <a:buNone/>
+              <a:tabLst/>
+              <a:defRPr/>
+            </a:pPr>
+            <a:r>
+              <a:rPr lang="en-US" sz="1200" dirty="0"/>
               <a:t>The advantage is that while accessing a block that is stored at the middle of a file, its location can be determined by chasing the pointers stored in the FAT as opposed to accessing all of the individual blocks of the file in a sequential manner to find the pointer to the target block. Typically, most of the FAT can be cached in memory and therefore the pointers can be determined with just memory accesses instead of having to access the disk blocks.</a:t>
             </a:r>
           </a:p>
@@ -7478,7 +7563,7 @@
 </p:notes>
 </file>
 
-<file path=ppt/notesSlides/notesSlide45.xml><?xml version="1.0" encoding="utf-8"?>
+<file path=ppt/notesSlides/notesSlide46.xml><?xml version="1.0" encoding="utf-8"?>
 <p:notes xmlns:a="http://schemas.openxmlformats.org/drawingml/2006/main" xmlns:r="http://schemas.openxmlformats.org/officeDocument/2006/relationships" xmlns:p="http://schemas.openxmlformats.org/presentationml/2006/main">
   <p:cSld>
     <p:spTree>
@@ -9294,7 +9379,7 @@
           <a:p>
             <a:fld id="{22E84849-4810-414A-ACFE-FE33101D47E1}" type="datetimeFigureOut">
               <a:rPr lang="en-SE" smtClean="0"/>
-              <a:t>7/14/26</a:t>
+              <a:t>8/17/26</a:t>
             </a:fld>
             <a:endParaRPr lang="en-SE"/>
           </a:p>
@@ -9494,7 +9579,7 @@
           <a:p>
             <a:fld id="{22E84849-4810-414A-ACFE-FE33101D47E1}" type="datetimeFigureOut">
               <a:rPr lang="en-SE" smtClean="0"/>
-              <a:t>7/14/26</a:t>
+              <a:t>8/17/26</a:t>
             </a:fld>
             <a:endParaRPr lang="en-SE"/>
           </a:p>
@@ -9770,7 +9855,7 @@
           <a:p>
             <a:fld id="{22E84849-4810-414A-ACFE-FE33101D47E1}" type="datetimeFigureOut">
               <a:rPr lang="en-SE" smtClean="0"/>
-              <a:t>7/14/26</a:t>
+              <a:t>8/17/26</a:t>
             </a:fld>
             <a:endParaRPr lang="en-SE"/>
           </a:p>
@@ -10038,7 +10123,7 @@
           <a:p>
             <a:fld id="{22E84849-4810-414A-ACFE-FE33101D47E1}" type="datetimeFigureOut">
               <a:rPr lang="en-SE" smtClean="0"/>
-              <a:t>7/14/26</a:t>
+              <a:t>8/17/26</a:t>
             </a:fld>
             <a:endParaRPr lang="en-SE"/>
           </a:p>
@@ -10453,7 +10538,7 @@
           <a:p>
             <a:fld id="{22E84849-4810-414A-ACFE-FE33101D47E1}" type="datetimeFigureOut">
               <a:rPr lang="en-SE" smtClean="0"/>
-              <a:t>7/14/26</a:t>
+              <a:t>8/17/26</a:t>
             </a:fld>
             <a:endParaRPr lang="en-SE"/>
           </a:p>
@@ -10595,7 +10680,7 @@
           <a:p>
             <a:fld id="{22E84849-4810-414A-ACFE-FE33101D47E1}" type="datetimeFigureOut">
               <a:rPr lang="en-SE" smtClean="0"/>
-              <a:t>7/14/26</a:t>
+              <a:t>8/17/26</a:t>
             </a:fld>
             <a:endParaRPr lang="en-SE"/>
           </a:p>
@@ -10708,7 +10793,7 @@
           <a:p>
             <a:fld id="{22E84849-4810-414A-ACFE-FE33101D47E1}" type="datetimeFigureOut">
               <a:rPr lang="en-SE" smtClean="0"/>
-              <a:t>7/14/26</a:t>
+              <a:t>8/17/26</a:t>
             </a:fld>
             <a:endParaRPr lang="en-SE"/>
           </a:p>
@@ -11192,7 +11277,7 @@
           <a:p>
             <a:fld id="{22E84849-4810-414A-ACFE-FE33101D47E1}" type="datetimeFigureOut">
               <a:rPr lang="en-SE" smtClean="0"/>
-              <a:t>7/14/26</a:t>
+              <a:t>8/17/26</a:t>
             </a:fld>
             <a:endParaRPr lang="en-SE"/>
           </a:p>
@@ -11481,7 +11566,7 @@
           <a:p>
             <a:fld id="{22E84849-4810-414A-ACFE-FE33101D47E1}" type="datetimeFigureOut">
               <a:rPr lang="en-SE" smtClean="0"/>
-              <a:t>7/14/26</a:t>
+              <a:t>8/17/26</a:t>
             </a:fld>
             <a:endParaRPr lang="en-SE"/>
           </a:p>
@@ -11681,7 +11766,7 @@
           <a:p>
             <a:fld id="{22E84849-4810-414A-ACFE-FE33101D47E1}" type="datetimeFigureOut">
               <a:rPr lang="en-SE" smtClean="0"/>
-              <a:t>7/14/26</a:t>
+              <a:t>8/17/26</a:t>
             </a:fld>
             <a:endParaRPr lang="en-SE"/>
           </a:p>
@@ -11891,7 +11976,7 @@
           <a:p>
             <a:fld id="{22E84849-4810-414A-ACFE-FE33101D47E1}" type="datetimeFigureOut">
               <a:rPr lang="en-SE" smtClean="0"/>
-              <a:t>7/14/26</a:t>
+              <a:t>8/17/26</a:t>
             </a:fld>
             <a:endParaRPr lang="en-SE"/>
           </a:p>
@@ -14336,7 +14421,7 @@
           <a:p>
             <a:fld id="{22E84849-4810-414A-ACFE-FE33101D47E1}" type="datetimeFigureOut">
               <a:rPr lang="en-SE" smtClean="0"/>
-              <a:t>7/14/26</a:t>
+              <a:t>8/17/26</a:t>
             </a:fld>
             <a:endParaRPr lang="en-SE"/>
           </a:p>
@@ -18844,14 +18929,14 @@
           </a:ln>
           <a:extLst>
             <a:ext uri="{909E8E84-426E-40dd-AFC4-6F175D3DCCD1}">
-              <a14:hiddenFill xmlns="" xmlns:a14="http://schemas.microsoft.com/office/drawing/2010/main">
+              <a14:hiddenFill xmlns:a14="http://schemas.microsoft.com/office/drawing/2010/main" xmlns="">
                 <a:solidFill>
                   <a:srgbClr val="FFFFFF"/>
                 </a:solidFill>
               </a14:hiddenFill>
             </a:ext>
             <a:ext uri="{91240B29-F687-4f45-9708-019B960494DF}">
-              <a14:hiddenLine xmlns="" xmlns:a14="http://schemas.microsoft.com/office/drawing/2010/main" w="9525">
+              <a14:hiddenLine xmlns:a14="http://schemas.microsoft.com/office/drawing/2010/main" xmlns="" w="9525">
                 <a:solidFill>
                   <a:srgbClr val="000000"/>
                 </a:solidFill>
@@ -20670,7 +20755,7 @@
             <p:nvPr/>
           </p:nvPicPr>
           <p:blipFill>
-            <a:blip r:embed="rId2"/>
+            <a:blip r:embed="rId3"/>
             <a:stretch>
               <a:fillRect/>
             </a:stretch>
@@ -21587,89 +21672,6 @@
   <p:clrMapOvr>
     <a:masterClrMapping/>
   </p:clrMapOvr>
-  <p:timing>
-    <p:tnLst>
-      <p:par>
-        <p:cTn id="1" dur="indefinite" restart="never" nodeType="tmRoot">
-          <p:childTnLst>
-            <p:seq concurrent="1" nextAc="seek">
-              <p:cTn id="2" dur="indefinite" nodeType="mainSeq">
-                <p:childTnLst>
-                  <p:par>
-                    <p:cTn id="3" fill="hold">
-                      <p:stCondLst>
-                        <p:cond delay="indefinite"/>
-                      </p:stCondLst>
-                      <p:childTnLst>
-                        <p:par>
-                          <p:cTn id="4" fill="hold">
-                            <p:stCondLst>
-                              <p:cond delay="0"/>
-                            </p:stCondLst>
-                            <p:childTnLst>
-                              <p:par>
-                                <p:cTn id="5" presetID="10" presetClass="entr" presetSubtype="0" fill="hold" nodeType="clickEffect">
-                                  <p:stCondLst>
-                                    <p:cond delay="0"/>
-                                  </p:stCondLst>
-                                  <p:childTnLst>
-                                    <p:set>
-                                      <p:cBhvr>
-                                        <p:cTn id="6" dur="1" fill="hold">
-                                          <p:stCondLst>
-                                            <p:cond delay="0"/>
-                                          </p:stCondLst>
-                                        </p:cTn>
-                                        <p:tgtEl>
-                                          <p:spTgt spid="3"/>
-                                        </p:tgtEl>
-                                        <p:attrNameLst>
-                                          <p:attrName>style.visibility</p:attrName>
-                                        </p:attrNameLst>
-                                      </p:cBhvr>
-                                      <p:to>
-                                        <p:strVal val="visible"/>
-                                      </p:to>
-                                    </p:set>
-                                    <p:animEffect transition="in" filter="fade">
-                                      <p:cBhvr>
-                                        <p:cTn id="7" dur="500"/>
-                                        <p:tgtEl>
-                                          <p:spTgt spid="3"/>
-                                        </p:tgtEl>
-                                      </p:cBhvr>
-                                    </p:animEffect>
-                                  </p:childTnLst>
-                                </p:cTn>
-                              </p:par>
-                            </p:childTnLst>
-                          </p:cTn>
-                        </p:par>
-                      </p:childTnLst>
-                    </p:cTn>
-                  </p:par>
-                </p:childTnLst>
-              </p:cTn>
-              <p:prevCondLst>
-                <p:cond evt="onPrev" delay="0">
-                  <p:tgtEl>
-                    <p:sldTgt/>
-                  </p:tgtEl>
-                </p:cond>
-              </p:prevCondLst>
-              <p:nextCondLst>
-                <p:cond evt="onNext" delay="0">
-                  <p:tgtEl>
-                    <p:sldTgt/>
-                  </p:tgtEl>
-                </p:cond>
-              </p:nextCondLst>
-            </p:seq>
-          </p:childTnLst>
-        </p:cTn>
-      </p:par>
-    </p:tnLst>
-  </p:timing>
 </p:sld>
 </file>
 

</xml_diff>